<commit_message>
Update submission status after repository upload
</commit_message>
<xml_diff>
--- a/submissions/BPMEA/Hospital_Pathway_BPMEA_Presentation_2026-09-29.pptx
+++ b/submissions/BPMEA/Hospital_Pathway_BPMEA_Presentation_2026-09-29.pptx
@@ -2,20 +2,20 @@
 <file path=ppt/presentation.xml><?xml version="1.0" encoding="utf-8"?>
 <p:presentation xmlns:p="http://schemas.openxmlformats.org/presentationml/2006/main">
   <p:sldMasterIdLst>
-    <p:sldMasterId xmlns:r="http://schemas.openxmlformats.org/officeDocument/2006/relationships" id="2147483648" r:id="R9215cf12ecf74aea"/>
+    <p:sldMasterId xmlns:r="http://schemas.openxmlformats.org/officeDocument/2006/relationships" id="2147483648" r:id="R838668c21d5b485f"/>
   </p:sldMasterIdLst>
   <p:notesMasterIdLst>
-    <p:notesMasterId xmlns:r="http://schemas.openxmlformats.org/officeDocument/2006/relationships" r:id="Rdeb6aec500ff4e15"/>
+    <p:notesMasterId xmlns:r="http://schemas.openxmlformats.org/officeDocument/2006/relationships" r:id="R4a3b2af5b99b4223"/>
   </p:notesMasterIdLst>
   <p:sldIdLst>
-    <p:sldId xmlns:r="http://schemas.openxmlformats.org/officeDocument/2006/relationships" id="256" r:id="Ra8831d6d71aa418d"/>
-    <p:sldId xmlns:r="http://schemas.openxmlformats.org/officeDocument/2006/relationships" id="257" r:id="Rd84331a864fe48bc"/>
-    <p:sldId xmlns:r="http://schemas.openxmlformats.org/officeDocument/2006/relationships" id="258" r:id="Rd53d919c427a4e58"/>
-    <p:sldId xmlns:r="http://schemas.openxmlformats.org/officeDocument/2006/relationships" id="259" r:id="R3f72c1dc101c4c3e"/>
-    <p:sldId xmlns:r="http://schemas.openxmlformats.org/officeDocument/2006/relationships" id="260" r:id="R024b37e188c14a34"/>
-    <p:sldId xmlns:r="http://schemas.openxmlformats.org/officeDocument/2006/relationships" id="261" r:id="R73982923a2194ec4"/>
-    <p:sldId xmlns:r="http://schemas.openxmlformats.org/officeDocument/2006/relationships" id="262" r:id="Rf53b81519ced4661"/>
-    <p:sldId xmlns:r="http://schemas.openxmlformats.org/officeDocument/2006/relationships" id="263" r:id="Rbaffce834ccd4f65"/>
+    <p:sldId xmlns:r="http://schemas.openxmlformats.org/officeDocument/2006/relationships" id="256" r:id="Re475bb6c31904c18"/>
+    <p:sldId xmlns:r="http://schemas.openxmlformats.org/officeDocument/2006/relationships" id="257" r:id="Rca744760d6034b1c"/>
+    <p:sldId xmlns:r="http://schemas.openxmlformats.org/officeDocument/2006/relationships" id="258" r:id="Rfa45b64035744e15"/>
+    <p:sldId xmlns:r="http://schemas.openxmlformats.org/officeDocument/2006/relationships" id="259" r:id="Rae0f001613fb4f58"/>
+    <p:sldId xmlns:r="http://schemas.openxmlformats.org/officeDocument/2006/relationships" id="260" r:id="R235e312bd3ae4466"/>
+    <p:sldId xmlns:r="http://schemas.openxmlformats.org/officeDocument/2006/relationships" id="261" r:id="R785b689564a24106"/>
+    <p:sldId xmlns:r="http://schemas.openxmlformats.org/officeDocument/2006/relationships" id="262" r:id="Rfe14bf6036dd47e6"/>
+    <p:sldId xmlns:r="http://schemas.openxmlformats.org/officeDocument/2006/relationships" id="263" r:id="R1b57e7678e4c4f10"/>
   </p:sldIdLst>
   <p:sldSz cx="12192000" cy="6858000"/>
   <p:notesSz cx="6858000" cy="9144000"/>
@@ -939,7 +939,7 @@
           <a:lstStyle xmlns:a="http://schemas.openxmlformats.org/drawingml/2006/main"/>
           <a:p xmlns:a="http://schemas.openxmlformats.org/drawingml/2006/main">
             <a:r>
-              <a:t>This is an evidence-bounded conclusion. The final G07 route passed in a local environment, while G03 is a known failure and G08-G11 still need owner-specific integration runs. The documents and deck are local additions until a team-reviewed Git commit and push. The earlier assessment materials mention strategic BPMN and i*; confirm against the definitive tutor brief rather than calling the operational Camunda file a strategic model.</a:t>
+              <a:t>This is an evidence-bounded conclusion. The final G07 route passed in a local environment, while G03 is a known failure and G08-G11 still need owner-specific integration runs. The submission pack was initially pushed to main in e8a6861 and still needs team review. The earlier assessment materials mention strategic BPMN and i*; confirm against the definitive tutor brief rather than calling the operational Camunda file a strategic model.</a:t>
             </a:r>
           </a:p>
         </p:txBody>
@@ -1007,7 +1007,7 @@
   </p:cSld>
   <p:clrMap bg1="lt1" tx1="dk1" bg2="lt2" tx2="dk2" accent1="accent1" accent2="accent2" accent3="accent3" accent4="accent4" accent5="accent5" accent6="accent6" hlink="hlink" folHlink="folHlink"/>
   <p:sldLayoutIdLst>
-    <p:sldLayoutId xmlns:r="http://schemas.openxmlformats.org/officeDocument/2006/relationships" id="2147483649" r:id="R9e3cf8373df84aea"/>
+    <p:sldLayoutId xmlns:r="http://schemas.openxmlformats.org/officeDocument/2006/relationships" id="2147483649" r:id="R0aecb4ea23ce4814"/>
   </p:sldLayoutIdLst>
   <p:txStyles>
     <p:titleStyle>
@@ -1558,7 +1558,7 @@
           <p:cNvPr id="8" name="">
             <a:extLst xmlns:a="http://schemas.openxmlformats.org/drawingml/2006/main">
               <a:ext uri="{FF2B5EF4-FFF2-40B4-BE49-F238E27FC236}">
-                <a16:creationId xmlns:a16="http://schemas.microsoft.com/office/drawing/2014/main" id="{A4CE5405-A1D3-41A9-BC9C-CF1EAD6F5221}"/>
+                <a16:creationId xmlns:a16="http://schemas.microsoft.com/office/drawing/2014/main" id="{50079355-5F42-47C1-9350-5B409ABBF9A9}"/>
               </a:ext>
             </a:extLst>
           </p:cNvPr>
@@ -1588,7 +1588,7 @@
           <p:cNvPr id="2" name="">
             <a:extLst xmlns:a="http://schemas.openxmlformats.org/drawingml/2006/main">
               <a:ext uri="{FF2B5EF4-FFF2-40B4-BE49-F238E27FC236}">
-                <a16:creationId xmlns:a16="http://schemas.microsoft.com/office/drawing/2014/main" id="{8FA7A454-88A4-43C2-929D-1CFF2888BC71}"/>
+                <a16:creationId xmlns:a16="http://schemas.microsoft.com/office/drawing/2014/main" id="{B5595F8E-EFE9-4EF8-B86A-2AF78D2C8B7F}"/>
               </a:ext>
             </a:extLst>
           </p:cNvPr>
@@ -1618,7 +1618,7 @@
           <p:cNvPr id="3" name="">
             <a:extLst xmlns:a="http://schemas.openxmlformats.org/drawingml/2006/main">
               <a:ext uri="{FF2B5EF4-FFF2-40B4-BE49-F238E27FC236}">
-                <a16:creationId xmlns:a16="http://schemas.microsoft.com/office/drawing/2014/main" id="{C14E32E0-C3E4-418E-B8FD-6886B1FDBE6D}"/>
+                <a16:creationId xmlns:a16="http://schemas.microsoft.com/office/drawing/2014/main" id="{5D0654C6-BA6C-4AFA-A1A9-A69ABDFD2170}"/>
               </a:ext>
             </a:extLst>
           </p:cNvPr>
@@ -1675,7 +1675,7 @@
           <p:cNvPr id="4" name="">
             <a:extLst xmlns:a="http://schemas.openxmlformats.org/drawingml/2006/main">
               <a:ext uri="{FF2B5EF4-FFF2-40B4-BE49-F238E27FC236}">
-                <a16:creationId xmlns:a16="http://schemas.microsoft.com/office/drawing/2014/main" id="{530DDC4C-4981-4DE6-BBC7-4F0960AF0225}"/>
+                <a16:creationId xmlns:a16="http://schemas.microsoft.com/office/drawing/2014/main" id="{1FD0D0B5-6279-42BF-90EB-3059A0D7D01D}"/>
               </a:ext>
             </a:extLst>
           </p:cNvPr>
@@ -1755,7 +1755,7 @@
           <p:cNvPr id="5" name="">
             <a:extLst xmlns:a="http://schemas.openxmlformats.org/drawingml/2006/main">
               <a:ext uri="{FF2B5EF4-FFF2-40B4-BE49-F238E27FC236}">
-                <a16:creationId xmlns:a16="http://schemas.microsoft.com/office/drawing/2014/main" id="{147A0F4A-7AA6-4756-9B86-3184394D33F2}"/>
+                <a16:creationId xmlns:a16="http://schemas.microsoft.com/office/drawing/2014/main" id="{C7B285BD-6D23-4141-AEB7-DFD2DDF5294A}"/>
               </a:ext>
             </a:extLst>
           </p:cNvPr>
@@ -1812,7 +1812,7 @@
           <p:cNvPr id="6" name="">
             <a:extLst xmlns:a="http://schemas.openxmlformats.org/drawingml/2006/main">
               <a:ext uri="{FF2B5EF4-FFF2-40B4-BE49-F238E27FC236}">
-                <a16:creationId xmlns:a16="http://schemas.microsoft.com/office/drawing/2014/main" id="{CB8AE1D3-EEC9-429E-8F01-39B023E8C376}"/>
+                <a16:creationId xmlns:a16="http://schemas.microsoft.com/office/drawing/2014/main" id="{23E3338B-6AF5-431D-BDE5-9A10BBEFFA84}"/>
               </a:ext>
             </a:extLst>
           </p:cNvPr>
@@ -1869,7 +1869,7 @@
           <p:cNvPr id="7" name="">
             <a:extLst xmlns:a="http://schemas.openxmlformats.org/drawingml/2006/main">
               <a:ext uri="{FF2B5EF4-FFF2-40B4-BE49-F238E27FC236}">
-                <a16:creationId xmlns:a16="http://schemas.microsoft.com/office/drawing/2014/main" id="{49BFE956-6A3E-4298-9949-7351918CF44E}"/>
+                <a16:creationId xmlns:a16="http://schemas.microsoft.com/office/drawing/2014/main" id="{2A63CD40-9EAB-446D-87BA-0357B2CCB099}"/>
               </a:ext>
             </a:extLst>
           </p:cNvPr>
@@ -1924,7 +1924,7 @@
     </p:spTree>
     <p:extLst>
       <p:ext uri="{BB962C8B-B14F-4D97-AF65-F5344CB8AC3E}">
-        <p14:creationId xmlns:p14="http://schemas.microsoft.com/office/powerpoint/2010/main" val="823329764"/>
+        <p14:creationId xmlns:p14="http://schemas.microsoft.com/office/powerpoint/2010/main" val="1353421470"/>
       </p:ext>
     </p:extLst>
   </p:cSld>
@@ -1955,7 +1955,7 @@
           <p:cNvPr id="25" name="">
             <a:extLst xmlns:a="http://schemas.openxmlformats.org/drawingml/2006/main">
               <a:ext uri="{FF2B5EF4-FFF2-40B4-BE49-F238E27FC236}">
-                <a16:creationId xmlns:a16="http://schemas.microsoft.com/office/drawing/2014/main" id="{2362353D-FA60-4FC2-86F5-BBA2E7DD5266}"/>
+                <a16:creationId xmlns:a16="http://schemas.microsoft.com/office/drawing/2014/main" id="{F9B7B190-A8C5-473A-A56D-1ADAD8F286D2}"/>
               </a:ext>
             </a:extLst>
           </p:cNvPr>
@@ -1985,7 +1985,7 @@
           <p:cNvPr id="2" name="">
             <a:extLst xmlns:a="http://schemas.openxmlformats.org/drawingml/2006/main">
               <a:ext uri="{FF2B5EF4-FFF2-40B4-BE49-F238E27FC236}">
-                <a16:creationId xmlns:a16="http://schemas.microsoft.com/office/drawing/2014/main" id="{1BB28C8C-B34B-4A9E-B2D6-FF121F3511E2}"/>
+                <a16:creationId xmlns:a16="http://schemas.microsoft.com/office/drawing/2014/main" id="{51639D33-0C44-48CE-B010-2AC9C8A949AC}"/>
               </a:ext>
             </a:extLst>
           </p:cNvPr>
@@ -2042,7 +2042,7 @@
           <p:cNvPr id="3" name="">
             <a:extLst xmlns:a="http://schemas.openxmlformats.org/drawingml/2006/main">
               <a:ext uri="{FF2B5EF4-FFF2-40B4-BE49-F238E27FC236}">
-                <a16:creationId xmlns:a16="http://schemas.microsoft.com/office/drawing/2014/main" id="{38387823-6F2E-4796-AEE5-CD734C1BBC8B}"/>
+                <a16:creationId xmlns:a16="http://schemas.microsoft.com/office/drawing/2014/main" id="{A4D66D0F-D19D-4ACB-9603-8516EB9D44AD}"/>
               </a:ext>
             </a:extLst>
           </p:cNvPr>
@@ -2099,7 +2099,7 @@
           <p:cNvPr id="4" name="">
             <a:extLst xmlns:a="http://schemas.openxmlformats.org/drawingml/2006/main">
               <a:ext uri="{FF2B5EF4-FFF2-40B4-BE49-F238E27FC236}">
-                <a16:creationId xmlns:a16="http://schemas.microsoft.com/office/drawing/2014/main" id="{54A235B5-770C-4E0A-8679-782C72886599}"/>
+                <a16:creationId xmlns:a16="http://schemas.microsoft.com/office/drawing/2014/main" id="{8DBBD269-FC37-4F4F-9795-46D737D613DA}"/>
               </a:ext>
             </a:extLst>
           </p:cNvPr>
@@ -2156,7 +2156,7 @@
           <p:cNvPr id="5" name="">
             <a:extLst xmlns:a="http://schemas.openxmlformats.org/drawingml/2006/main">
               <a:ext uri="{FF2B5EF4-FFF2-40B4-BE49-F238E27FC236}">
-                <a16:creationId xmlns:a16="http://schemas.microsoft.com/office/drawing/2014/main" id="{76F9DB26-1E8E-4512-B881-B3A2B1B1233E}"/>
+                <a16:creationId xmlns:a16="http://schemas.microsoft.com/office/drawing/2014/main" id="{CB3FE4A6-90EC-400F-B345-BFCD7A3C3A23}"/>
               </a:ext>
             </a:extLst>
           </p:cNvPr>
@@ -2186,7 +2186,7 @@
           <p:cNvPr id="6" name="">
             <a:extLst xmlns:a="http://schemas.openxmlformats.org/drawingml/2006/main">
               <a:ext uri="{FF2B5EF4-FFF2-40B4-BE49-F238E27FC236}">
-                <a16:creationId xmlns:a16="http://schemas.microsoft.com/office/drawing/2014/main" id="{6CB167B4-D608-4280-8C65-D190C69E5B79}"/>
+                <a16:creationId xmlns:a16="http://schemas.microsoft.com/office/drawing/2014/main" id="{792708C5-332E-438C-8D3B-56D6500DBF45}"/>
               </a:ext>
             </a:extLst>
           </p:cNvPr>
@@ -2243,7 +2243,7 @@
           <p:cNvPr id="7" name="">
             <a:extLst xmlns:a="http://schemas.openxmlformats.org/drawingml/2006/main">
               <a:ext uri="{FF2B5EF4-FFF2-40B4-BE49-F238E27FC236}">
-                <a16:creationId xmlns:a16="http://schemas.microsoft.com/office/drawing/2014/main" id="{638D61DC-547A-4BB8-9D66-8527B0734525}"/>
+                <a16:creationId xmlns:a16="http://schemas.microsoft.com/office/drawing/2014/main" id="{BB461397-4F44-4E7E-B222-C62C4BECC7C3}"/>
               </a:ext>
             </a:extLst>
           </p:cNvPr>
@@ -2300,7 +2300,7 @@
           <p:cNvPr id="8" name="">
             <a:extLst xmlns:a="http://schemas.openxmlformats.org/drawingml/2006/main">
               <a:ext uri="{FF2B5EF4-FFF2-40B4-BE49-F238E27FC236}">
-                <a16:creationId xmlns:a16="http://schemas.microsoft.com/office/drawing/2014/main" id="{A354108F-9E85-4DC6-AD6D-C0AD5A383136}"/>
+                <a16:creationId xmlns:a16="http://schemas.microsoft.com/office/drawing/2014/main" id="{A2F5B6A2-ADB0-4F07-ACF5-75AB9576AA08}"/>
               </a:ext>
             </a:extLst>
           </p:cNvPr>
@@ -2334,7 +2334,7 @@
           <p:cNvPr id="9" name="">
             <a:extLst xmlns:a="http://schemas.openxmlformats.org/drawingml/2006/main">
               <a:ext uri="{FF2B5EF4-FFF2-40B4-BE49-F238E27FC236}">
-                <a16:creationId xmlns:a16="http://schemas.microsoft.com/office/drawing/2014/main" id="{63B06F05-BF9B-4A9E-B897-05AB8EA90F72}"/>
+                <a16:creationId xmlns:a16="http://schemas.microsoft.com/office/drawing/2014/main" id="{F4AD7C42-4E45-4B9A-B793-BA5617E8D712}"/>
               </a:ext>
             </a:extLst>
           </p:cNvPr>
@@ -2364,7 +2364,7 @@
           <p:cNvPr id="10" name="">
             <a:extLst xmlns:a="http://schemas.openxmlformats.org/drawingml/2006/main">
               <a:ext uri="{FF2B5EF4-FFF2-40B4-BE49-F238E27FC236}">
-                <a16:creationId xmlns:a16="http://schemas.microsoft.com/office/drawing/2014/main" id="{A2101C67-E64C-4BB9-9198-396FBD9EAD6A}"/>
+                <a16:creationId xmlns:a16="http://schemas.microsoft.com/office/drawing/2014/main" id="{5B3F97FD-59B0-4F2C-82A4-C9BDDCB7B774}"/>
               </a:ext>
             </a:extLst>
           </p:cNvPr>
@@ -2421,7 +2421,7 @@
           <p:cNvPr id="11" name="">
             <a:extLst xmlns:a="http://schemas.openxmlformats.org/drawingml/2006/main">
               <a:ext uri="{FF2B5EF4-FFF2-40B4-BE49-F238E27FC236}">
-                <a16:creationId xmlns:a16="http://schemas.microsoft.com/office/drawing/2014/main" id="{B8D6C27E-3196-4014-AE5C-18DC0A34BDAB}"/>
+                <a16:creationId xmlns:a16="http://schemas.microsoft.com/office/drawing/2014/main" id="{D5622F96-DB6D-45C1-8F8E-3E27FD04FC23}"/>
               </a:ext>
             </a:extLst>
           </p:cNvPr>
@@ -2478,7 +2478,7 @@
           <p:cNvPr id="12" name="">
             <a:extLst xmlns:a="http://schemas.openxmlformats.org/drawingml/2006/main">
               <a:ext uri="{FF2B5EF4-FFF2-40B4-BE49-F238E27FC236}">
-                <a16:creationId xmlns:a16="http://schemas.microsoft.com/office/drawing/2014/main" id="{31F18C5E-F6AE-48BF-B45B-4934A82F86DA}"/>
+                <a16:creationId xmlns:a16="http://schemas.microsoft.com/office/drawing/2014/main" id="{E8ED6484-0119-4D84-A490-7BD0CA255E7A}"/>
               </a:ext>
             </a:extLst>
           </p:cNvPr>
@@ -2512,7 +2512,7 @@
           <p:cNvPr id="13" name="">
             <a:extLst xmlns:a="http://schemas.openxmlformats.org/drawingml/2006/main">
               <a:ext uri="{FF2B5EF4-FFF2-40B4-BE49-F238E27FC236}">
-                <a16:creationId xmlns:a16="http://schemas.microsoft.com/office/drawing/2014/main" id="{3B5F8CFA-14D3-4B96-AA47-125D1CFBD224}"/>
+                <a16:creationId xmlns:a16="http://schemas.microsoft.com/office/drawing/2014/main" id="{B12F01E4-6FCA-444E-A69F-E80D954BEC42}"/>
               </a:ext>
             </a:extLst>
           </p:cNvPr>
@@ -2542,7 +2542,7 @@
           <p:cNvPr id="14" name="">
             <a:extLst xmlns:a="http://schemas.openxmlformats.org/drawingml/2006/main">
               <a:ext uri="{FF2B5EF4-FFF2-40B4-BE49-F238E27FC236}">
-                <a16:creationId xmlns:a16="http://schemas.microsoft.com/office/drawing/2014/main" id="{556D003B-BF66-4416-929F-C355725EF72A}"/>
+                <a16:creationId xmlns:a16="http://schemas.microsoft.com/office/drawing/2014/main" id="{6B773D93-409F-4645-AB21-2637199DA125}"/>
               </a:ext>
             </a:extLst>
           </p:cNvPr>
@@ -2599,7 +2599,7 @@
           <p:cNvPr id="15" name="">
             <a:extLst xmlns:a="http://schemas.openxmlformats.org/drawingml/2006/main">
               <a:ext uri="{FF2B5EF4-FFF2-40B4-BE49-F238E27FC236}">
-                <a16:creationId xmlns:a16="http://schemas.microsoft.com/office/drawing/2014/main" id="{A3CF8342-A315-4BF9-AC0B-089B72B2F5C5}"/>
+                <a16:creationId xmlns:a16="http://schemas.microsoft.com/office/drawing/2014/main" id="{6907EB64-1370-4DCC-8CFA-DFB1F06A2E20}"/>
               </a:ext>
             </a:extLst>
           </p:cNvPr>
@@ -2656,7 +2656,7 @@
           <p:cNvPr id="16" name="">
             <a:extLst xmlns:a="http://schemas.openxmlformats.org/drawingml/2006/main">
               <a:ext uri="{FF2B5EF4-FFF2-40B4-BE49-F238E27FC236}">
-                <a16:creationId xmlns:a16="http://schemas.microsoft.com/office/drawing/2014/main" id="{AE0344E1-173D-4714-94AB-8E1F478D12D9}"/>
+                <a16:creationId xmlns:a16="http://schemas.microsoft.com/office/drawing/2014/main" id="{4580F688-5860-41AD-997F-A4059822FD28}"/>
               </a:ext>
             </a:extLst>
           </p:cNvPr>
@@ -2690,7 +2690,7 @@
           <p:cNvPr id="17" name="">
             <a:extLst xmlns:a="http://schemas.openxmlformats.org/drawingml/2006/main">
               <a:ext uri="{FF2B5EF4-FFF2-40B4-BE49-F238E27FC236}">
-                <a16:creationId xmlns:a16="http://schemas.microsoft.com/office/drawing/2014/main" id="{078D9A1F-07EA-419F-AE5E-95070CFBA0D4}"/>
+                <a16:creationId xmlns:a16="http://schemas.microsoft.com/office/drawing/2014/main" id="{2B9358B1-F29A-4437-8EEC-93371EBB3838}"/>
               </a:ext>
             </a:extLst>
           </p:cNvPr>
@@ -2720,7 +2720,7 @@
           <p:cNvPr id="18" name="">
             <a:extLst xmlns:a="http://schemas.openxmlformats.org/drawingml/2006/main">
               <a:ext uri="{FF2B5EF4-FFF2-40B4-BE49-F238E27FC236}">
-                <a16:creationId xmlns:a16="http://schemas.microsoft.com/office/drawing/2014/main" id="{C0FB975B-330B-4C68-9C0B-DE1E3F04AF85}"/>
+                <a16:creationId xmlns:a16="http://schemas.microsoft.com/office/drawing/2014/main" id="{B2C485DA-2B5F-4107-867E-B68A33130065}"/>
               </a:ext>
             </a:extLst>
           </p:cNvPr>
@@ -2777,7 +2777,7 @@
           <p:cNvPr id="19" name="">
             <a:extLst xmlns:a="http://schemas.openxmlformats.org/drawingml/2006/main">
               <a:ext uri="{FF2B5EF4-FFF2-40B4-BE49-F238E27FC236}">
-                <a16:creationId xmlns:a16="http://schemas.microsoft.com/office/drawing/2014/main" id="{5685473B-9A49-4EF5-B316-593620E9F826}"/>
+                <a16:creationId xmlns:a16="http://schemas.microsoft.com/office/drawing/2014/main" id="{081C2AE1-30A4-4802-91A4-89F8D23CCAA3}"/>
               </a:ext>
             </a:extLst>
           </p:cNvPr>
@@ -2834,7 +2834,7 @@
           <p:cNvPr id="20" name="">
             <a:extLst xmlns:a="http://schemas.openxmlformats.org/drawingml/2006/main">
               <a:ext uri="{FF2B5EF4-FFF2-40B4-BE49-F238E27FC236}">
-                <a16:creationId xmlns:a16="http://schemas.microsoft.com/office/drawing/2014/main" id="{F4F69E63-7407-4C39-9CC9-7E785EBCCE6F}"/>
+                <a16:creationId xmlns:a16="http://schemas.microsoft.com/office/drawing/2014/main" id="{10A3A049-D0EF-443C-B9D1-F05E838A7122}"/>
               </a:ext>
             </a:extLst>
           </p:cNvPr>
@@ -2868,7 +2868,7 @@
           <p:cNvPr id="21" name="">
             <a:extLst xmlns:a="http://schemas.openxmlformats.org/drawingml/2006/main">
               <a:ext uri="{FF2B5EF4-FFF2-40B4-BE49-F238E27FC236}">
-                <a16:creationId xmlns:a16="http://schemas.microsoft.com/office/drawing/2014/main" id="{B7FF3C56-100A-41CC-8950-CF06808B22C3}"/>
+                <a16:creationId xmlns:a16="http://schemas.microsoft.com/office/drawing/2014/main" id="{54261F08-CC64-4AFA-A3DE-BFE42546EEF0}"/>
               </a:ext>
             </a:extLst>
           </p:cNvPr>
@@ -2898,7 +2898,7 @@
           <p:cNvPr id="22" name="">
             <a:extLst xmlns:a="http://schemas.openxmlformats.org/drawingml/2006/main">
               <a:ext uri="{FF2B5EF4-FFF2-40B4-BE49-F238E27FC236}">
-                <a16:creationId xmlns:a16="http://schemas.microsoft.com/office/drawing/2014/main" id="{24786AE6-D6BF-4F46-A8A1-16BA202CF461}"/>
+                <a16:creationId xmlns:a16="http://schemas.microsoft.com/office/drawing/2014/main" id="{C2128763-BE32-45A5-809A-7E98FE9F44CD}"/>
               </a:ext>
             </a:extLst>
           </p:cNvPr>
@@ -2955,7 +2955,7 @@
           <p:cNvPr id="23" name="">
             <a:extLst xmlns:a="http://schemas.openxmlformats.org/drawingml/2006/main">
               <a:ext uri="{FF2B5EF4-FFF2-40B4-BE49-F238E27FC236}">
-                <a16:creationId xmlns:a16="http://schemas.microsoft.com/office/drawing/2014/main" id="{AEF9EEBC-3E07-4158-AB03-F200D13BDA0D}"/>
+                <a16:creationId xmlns:a16="http://schemas.microsoft.com/office/drawing/2014/main" id="{4B3386BC-95E1-4EA5-A149-E89E01B377C0}"/>
               </a:ext>
             </a:extLst>
           </p:cNvPr>
@@ -3012,7 +3012,7 @@
           <p:cNvPr id="24" name="">
             <a:extLst xmlns:a="http://schemas.openxmlformats.org/drawingml/2006/main">
               <a:ext uri="{FF2B5EF4-FFF2-40B4-BE49-F238E27FC236}">
-                <a16:creationId xmlns:a16="http://schemas.microsoft.com/office/drawing/2014/main" id="{294547AF-B9C5-47AD-92CB-C2377347A75C}"/>
+                <a16:creationId xmlns:a16="http://schemas.microsoft.com/office/drawing/2014/main" id="{570C69DF-20B6-4748-99A1-A9A9855D753B}"/>
               </a:ext>
             </a:extLst>
           </p:cNvPr>
@@ -3067,7 +3067,7 @@
     </p:spTree>
     <p:extLst>
       <p:ext uri="{BB962C8B-B14F-4D97-AF65-F5344CB8AC3E}">
-        <p14:creationId xmlns:p14="http://schemas.microsoft.com/office/powerpoint/2010/main" val="45434747"/>
+        <p14:creationId xmlns:p14="http://schemas.microsoft.com/office/powerpoint/2010/main" val="1228402632"/>
       </p:ext>
     </p:extLst>
   </p:cSld>
@@ -3098,7 +3098,7 @@
           <p:cNvPr id="30" name="">
             <a:extLst xmlns:a="http://schemas.openxmlformats.org/drawingml/2006/main">
               <a:ext uri="{FF2B5EF4-FFF2-40B4-BE49-F238E27FC236}">
-                <a16:creationId xmlns:a16="http://schemas.microsoft.com/office/drawing/2014/main" id="{D75674C0-96E5-4584-AC5E-606B1407369A}"/>
+                <a16:creationId xmlns:a16="http://schemas.microsoft.com/office/drawing/2014/main" id="{795851EC-C363-4A4C-B520-12BAD271BC8A}"/>
               </a:ext>
             </a:extLst>
           </p:cNvPr>
@@ -3128,7 +3128,7 @@
           <p:cNvPr id="2" name="">
             <a:extLst xmlns:a="http://schemas.openxmlformats.org/drawingml/2006/main">
               <a:ext uri="{FF2B5EF4-FFF2-40B4-BE49-F238E27FC236}">
-                <a16:creationId xmlns:a16="http://schemas.microsoft.com/office/drawing/2014/main" id="{1F13B8F7-0D36-4756-BE4F-1903CB6227A7}"/>
+                <a16:creationId xmlns:a16="http://schemas.microsoft.com/office/drawing/2014/main" id="{04E445E8-32E8-4B8E-B16E-C474EA23E1A6}"/>
               </a:ext>
             </a:extLst>
           </p:cNvPr>
@@ -3185,7 +3185,7 @@
           <p:cNvPr id="3" name="">
             <a:extLst xmlns:a="http://schemas.openxmlformats.org/drawingml/2006/main">
               <a:ext uri="{FF2B5EF4-FFF2-40B4-BE49-F238E27FC236}">
-                <a16:creationId xmlns:a16="http://schemas.microsoft.com/office/drawing/2014/main" id="{989BF44F-CAC5-4E21-9DAC-CED5751082CD}"/>
+                <a16:creationId xmlns:a16="http://schemas.microsoft.com/office/drawing/2014/main" id="{40512BAD-3832-4659-A33A-BC2C4D72249B}"/>
               </a:ext>
             </a:extLst>
           </p:cNvPr>
@@ -3242,7 +3242,7 @@
           <p:cNvPr id="4" name="">
             <a:extLst xmlns:a="http://schemas.openxmlformats.org/drawingml/2006/main">
               <a:ext uri="{FF2B5EF4-FFF2-40B4-BE49-F238E27FC236}">
-                <a16:creationId xmlns:a16="http://schemas.microsoft.com/office/drawing/2014/main" id="{47E45D5C-3790-4152-B6CC-0A7AADAC0672}"/>
+                <a16:creationId xmlns:a16="http://schemas.microsoft.com/office/drawing/2014/main" id="{3A59420C-2B3B-43B8-BAEC-3987080842D3}"/>
               </a:ext>
             </a:extLst>
           </p:cNvPr>
@@ -3299,7 +3299,7 @@
           <p:cNvPr id="5" name="">
             <a:extLst xmlns:a="http://schemas.openxmlformats.org/drawingml/2006/main">
               <a:ext uri="{FF2B5EF4-FFF2-40B4-BE49-F238E27FC236}">
-                <a16:creationId xmlns:a16="http://schemas.microsoft.com/office/drawing/2014/main" id="{693300C0-B0B3-4AEC-8FC2-E6D1D5554454}"/>
+                <a16:creationId xmlns:a16="http://schemas.microsoft.com/office/drawing/2014/main" id="{E9C53EA3-58FA-40A5-9E7F-394307577700}"/>
               </a:ext>
             </a:extLst>
           </p:cNvPr>
@@ -3329,7 +3329,7 @@
           <p:cNvPr id="6" name="">
             <a:extLst xmlns:a="http://schemas.openxmlformats.org/drawingml/2006/main">
               <a:ext uri="{FF2B5EF4-FFF2-40B4-BE49-F238E27FC236}">
-                <a16:creationId xmlns:a16="http://schemas.microsoft.com/office/drawing/2014/main" id="{3F7E9AD0-B2C2-4552-AB4D-C5DCBF5C8E74}"/>
+                <a16:creationId xmlns:a16="http://schemas.microsoft.com/office/drawing/2014/main" id="{573CA1F1-8447-4D78-89B7-D80D00798FB7}"/>
               </a:ext>
             </a:extLst>
           </p:cNvPr>
@@ -3386,7 +3386,7 @@
           <p:cNvPr id="7" name="">
             <a:extLst xmlns:a="http://schemas.openxmlformats.org/drawingml/2006/main">
               <a:ext uri="{FF2B5EF4-FFF2-40B4-BE49-F238E27FC236}">
-                <a16:creationId xmlns:a16="http://schemas.microsoft.com/office/drawing/2014/main" id="{8DD95422-25EB-4485-ACF8-F42B19C3A805}"/>
+                <a16:creationId xmlns:a16="http://schemas.microsoft.com/office/drawing/2014/main" id="{56989FA1-415C-4C93-A23E-6034DE917655}"/>
               </a:ext>
             </a:extLst>
           </p:cNvPr>
@@ -3443,7 +3443,7 @@
           <p:cNvPr id="8" name="">
             <a:extLst xmlns:a="http://schemas.openxmlformats.org/drawingml/2006/main">
               <a:ext uri="{FF2B5EF4-FFF2-40B4-BE49-F238E27FC236}">
-                <a16:creationId xmlns:a16="http://schemas.microsoft.com/office/drawing/2014/main" id="{2F8C5E1F-10F4-4174-8E81-C31DD3E455E0}"/>
+                <a16:creationId xmlns:a16="http://schemas.microsoft.com/office/drawing/2014/main" id="{F56F7BAB-5F13-40EB-9E30-E1EE73303666}"/>
               </a:ext>
             </a:extLst>
           </p:cNvPr>
@@ -3477,7 +3477,7 @@
           <p:cNvPr id="9" name="">
             <a:extLst xmlns:a="http://schemas.openxmlformats.org/drawingml/2006/main">
               <a:ext uri="{FF2B5EF4-FFF2-40B4-BE49-F238E27FC236}">
-                <a16:creationId xmlns:a16="http://schemas.microsoft.com/office/drawing/2014/main" id="{E3F36F8F-6357-4328-9E5A-5C642A975DBC}"/>
+                <a16:creationId xmlns:a16="http://schemas.microsoft.com/office/drawing/2014/main" id="{F8EE0C96-13FF-4538-8318-4E60C160BBA6}"/>
               </a:ext>
             </a:extLst>
           </p:cNvPr>
@@ -3507,7 +3507,7 @@
           <p:cNvPr id="10" name="">
             <a:extLst xmlns:a="http://schemas.openxmlformats.org/drawingml/2006/main">
               <a:ext uri="{FF2B5EF4-FFF2-40B4-BE49-F238E27FC236}">
-                <a16:creationId xmlns:a16="http://schemas.microsoft.com/office/drawing/2014/main" id="{373A9FB3-7974-48CA-9721-C8D2BD6A6E63}"/>
+                <a16:creationId xmlns:a16="http://schemas.microsoft.com/office/drawing/2014/main" id="{9BF65656-9ADF-4F5B-81C5-528F0B5A8C56}"/>
               </a:ext>
             </a:extLst>
           </p:cNvPr>
@@ -3564,7 +3564,7 @@
           <p:cNvPr id="11" name="">
             <a:extLst xmlns:a="http://schemas.openxmlformats.org/drawingml/2006/main">
               <a:ext uri="{FF2B5EF4-FFF2-40B4-BE49-F238E27FC236}">
-                <a16:creationId xmlns:a16="http://schemas.microsoft.com/office/drawing/2014/main" id="{FCA545AD-77F9-4A5E-B88D-E16E32D0FC0E}"/>
+                <a16:creationId xmlns:a16="http://schemas.microsoft.com/office/drawing/2014/main" id="{5EDA1DBD-5F56-48D3-921E-20864FBC9798}"/>
               </a:ext>
             </a:extLst>
           </p:cNvPr>
@@ -3621,7 +3621,7 @@
           <p:cNvPr id="12" name="">
             <a:extLst xmlns:a="http://schemas.openxmlformats.org/drawingml/2006/main">
               <a:ext uri="{FF2B5EF4-FFF2-40B4-BE49-F238E27FC236}">
-                <a16:creationId xmlns:a16="http://schemas.microsoft.com/office/drawing/2014/main" id="{7388F195-8A5B-4AFC-BABC-9241CDE58B13}"/>
+                <a16:creationId xmlns:a16="http://schemas.microsoft.com/office/drawing/2014/main" id="{0E7C9493-F8A4-4CE8-B722-58FB742BED68}"/>
               </a:ext>
             </a:extLst>
           </p:cNvPr>
@@ -3678,7 +3678,7 @@
           <p:cNvPr id="13" name="">
             <a:extLst xmlns:a="http://schemas.openxmlformats.org/drawingml/2006/main">
               <a:ext uri="{FF2B5EF4-FFF2-40B4-BE49-F238E27FC236}">
-                <a16:creationId xmlns:a16="http://schemas.microsoft.com/office/drawing/2014/main" id="{1A41BE87-2E50-44DD-9AEB-89DB4D5E011F}"/>
+                <a16:creationId xmlns:a16="http://schemas.microsoft.com/office/drawing/2014/main" id="{5CFEE3E4-2D1A-480F-8DDD-A98586761651}"/>
               </a:ext>
             </a:extLst>
           </p:cNvPr>
@@ -3712,7 +3712,7 @@
           <p:cNvPr id="14" name="">
             <a:extLst xmlns:a="http://schemas.openxmlformats.org/drawingml/2006/main">
               <a:ext uri="{FF2B5EF4-FFF2-40B4-BE49-F238E27FC236}">
-                <a16:creationId xmlns:a16="http://schemas.microsoft.com/office/drawing/2014/main" id="{6A65E7AD-AEBD-4925-B267-5D11CF8F40A1}"/>
+                <a16:creationId xmlns:a16="http://schemas.microsoft.com/office/drawing/2014/main" id="{5B82E26C-6E15-4108-89B1-0D19F5FC0C12}"/>
               </a:ext>
             </a:extLst>
           </p:cNvPr>
@@ -3742,7 +3742,7 @@
           <p:cNvPr id="15" name="">
             <a:extLst xmlns:a="http://schemas.openxmlformats.org/drawingml/2006/main">
               <a:ext uri="{FF2B5EF4-FFF2-40B4-BE49-F238E27FC236}">
-                <a16:creationId xmlns:a16="http://schemas.microsoft.com/office/drawing/2014/main" id="{3BAB9921-B7BF-4952-A301-C3BB6D954094}"/>
+                <a16:creationId xmlns:a16="http://schemas.microsoft.com/office/drawing/2014/main" id="{C1B9FD2D-5212-4F9E-A43C-95D8C5C0142C}"/>
               </a:ext>
             </a:extLst>
           </p:cNvPr>
@@ -3799,7 +3799,7 @@
           <p:cNvPr id="16" name="">
             <a:extLst xmlns:a="http://schemas.openxmlformats.org/drawingml/2006/main">
               <a:ext uri="{FF2B5EF4-FFF2-40B4-BE49-F238E27FC236}">
-                <a16:creationId xmlns:a16="http://schemas.microsoft.com/office/drawing/2014/main" id="{E9140D83-994C-4E51-84CA-C2EFFE71EC00}"/>
+                <a16:creationId xmlns:a16="http://schemas.microsoft.com/office/drawing/2014/main" id="{8985A760-7A56-42DE-9479-37FB81C5358F}"/>
               </a:ext>
             </a:extLst>
           </p:cNvPr>
@@ -3856,7 +3856,7 @@
           <p:cNvPr id="17" name="">
             <a:extLst xmlns:a="http://schemas.openxmlformats.org/drawingml/2006/main">
               <a:ext uri="{FF2B5EF4-FFF2-40B4-BE49-F238E27FC236}">
-                <a16:creationId xmlns:a16="http://schemas.microsoft.com/office/drawing/2014/main" id="{C6020AB4-D088-46C3-9989-288DF941CFF5}"/>
+                <a16:creationId xmlns:a16="http://schemas.microsoft.com/office/drawing/2014/main" id="{154A904A-2856-4B36-A0EB-4F8ADF434602}"/>
               </a:ext>
             </a:extLst>
           </p:cNvPr>
@@ -3913,7 +3913,7 @@
           <p:cNvPr id="18" name="">
             <a:extLst xmlns:a="http://schemas.openxmlformats.org/drawingml/2006/main">
               <a:ext uri="{FF2B5EF4-FFF2-40B4-BE49-F238E27FC236}">
-                <a16:creationId xmlns:a16="http://schemas.microsoft.com/office/drawing/2014/main" id="{2FCEE695-B040-422A-9CCC-C36E15D05D39}"/>
+                <a16:creationId xmlns:a16="http://schemas.microsoft.com/office/drawing/2014/main" id="{9A3CBA1E-9172-428B-B06C-43D643CA694F}"/>
               </a:ext>
             </a:extLst>
           </p:cNvPr>
@@ -3947,7 +3947,7 @@
           <p:cNvPr id="19" name="">
             <a:extLst xmlns:a="http://schemas.openxmlformats.org/drawingml/2006/main">
               <a:ext uri="{FF2B5EF4-FFF2-40B4-BE49-F238E27FC236}">
-                <a16:creationId xmlns:a16="http://schemas.microsoft.com/office/drawing/2014/main" id="{4BA12A7C-2F3F-443F-BA5E-9E0B6D83905E}"/>
+                <a16:creationId xmlns:a16="http://schemas.microsoft.com/office/drawing/2014/main" id="{83D11CBA-AC34-4359-8329-3D03C30ADA50}"/>
               </a:ext>
             </a:extLst>
           </p:cNvPr>
@@ -3977,7 +3977,7 @@
           <p:cNvPr id="20" name="">
             <a:extLst xmlns:a="http://schemas.openxmlformats.org/drawingml/2006/main">
               <a:ext uri="{FF2B5EF4-FFF2-40B4-BE49-F238E27FC236}">
-                <a16:creationId xmlns:a16="http://schemas.microsoft.com/office/drawing/2014/main" id="{817222DE-88B9-4C56-9F06-7E61407C6955}"/>
+                <a16:creationId xmlns:a16="http://schemas.microsoft.com/office/drawing/2014/main" id="{F99D6DB8-905D-4650-B59B-0A256B71CC39}"/>
               </a:ext>
             </a:extLst>
           </p:cNvPr>
@@ -4034,7 +4034,7 @@
           <p:cNvPr id="21" name="">
             <a:extLst xmlns:a="http://schemas.openxmlformats.org/drawingml/2006/main">
               <a:ext uri="{FF2B5EF4-FFF2-40B4-BE49-F238E27FC236}">
-                <a16:creationId xmlns:a16="http://schemas.microsoft.com/office/drawing/2014/main" id="{9AFC5C8B-E7E7-4D2E-8896-50F1E0222418}"/>
+                <a16:creationId xmlns:a16="http://schemas.microsoft.com/office/drawing/2014/main" id="{3026426B-0E67-4352-8742-6313992DBE16}"/>
               </a:ext>
             </a:extLst>
           </p:cNvPr>
@@ -4091,7 +4091,7 @@
           <p:cNvPr id="22" name="">
             <a:extLst xmlns:a="http://schemas.openxmlformats.org/drawingml/2006/main">
               <a:ext uri="{FF2B5EF4-FFF2-40B4-BE49-F238E27FC236}">
-                <a16:creationId xmlns:a16="http://schemas.microsoft.com/office/drawing/2014/main" id="{D7D083D5-713F-469E-8CE6-DE7B4CEB0C19}"/>
+                <a16:creationId xmlns:a16="http://schemas.microsoft.com/office/drawing/2014/main" id="{9F1A0387-1872-4D2E-956D-09075D672218}"/>
               </a:ext>
             </a:extLst>
           </p:cNvPr>
@@ -4148,7 +4148,7 @@
           <p:cNvPr id="23" name="">
             <a:extLst xmlns:a="http://schemas.openxmlformats.org/drawingml/2006/main">
               <a:ext uri="{FF2B5EF4-FFF2-40B4-BE49-F238E27FC236}">
-                <a16:creationId xmlns:a16="http://schemas.microsoft.com/office/drawing/2014/main" id="{E3BB5A68-7422-458A-9663-022964541F1A}"/>
+                <a16:creationId xmlns:a16="http://schemas.microsoft.com/office/drawing/2014/main" id="{792495C5-933E-492E-A7E0-4C48EA080556}"/>
               </a:ext>
             </a:extLst>
           </p:cNvPr>
@@ -4182,7 +4182,7 @@
           <p:cNvPr id="24" name="">
             <a:extLst xmlns:a="http://schemas.openxmlformats.org/drawingml/2006/main">
               <a:ext uri="{FF2B5EF4-FFF2-40B4-BE49-F238E27FC236}">
-                <a16:creationId xmlns:a16="http://schemas.microsoft.com/office/drawing/2014/main" id="{7F2D75C2-FC2B-41FB-A3E6-1435E02E79B1}"/>
+                <a16:creationId xmlns:a16="http://schemas.microsoft.com/office/drawing/2014/main" id="{C7FFBE95-F607-4ED0-A954-2373E07147F9}"/>
               </a:ext>
             </a:extLst>
           </p:cNvPr>
@@ -4212,7 +4212,7 @@
           <p:cNvPr id="25" name="">
             <a:extLst xmlns:a="http://schemas.openxmlformats.org/drawingml/2006/main">
               <a:ext uri="{FF2B5EF4-FFF2-40B4-BE49-F238E27FC236}">
-                <a16:creationId xmlns:a16="http://schemas.microsoft.com/office/drawing/2014/main" id="{F31A31A1-0C61-4168-8D1D-5082F8E8CB83}"/>
+                <a16:creationId xmlns:a16="http://schemas.microsoft.com/office/drawing/2014/main" id="{43B03C00-C77F-465E-B801-F96B0C3B269A}"/>
               </a:ext>
             </a:extLst>
           </p:cNvPr>
@@ -4269,7 +4269,7 @@
           <p:cNvPr id="26" name="">
             <a:extLst xmlns:a="http://schemas.openxmlformats.org/drawingml/2006/main">
               <a:ext uri="{FF2B5EF4-FFF2-40B4-BE49-F238E27FC236}">
-                <a16:creationId xmlns:a16="http://schemas.microsoft.com/office/drawing/2014/main" id="{65A2CC1D-DB92-4B09-A1C7-82FF79ABD6A9}"/>
+                <a16:creationId xmlns:a16="http://schemas.microsoft.com/office/drawing/2014/main" id="{60B2DD1F-2FBD-445D-889C-928BB28967D6}"/>
               </a:ext>
             </a:extLst>
           </p:cNvPr>
@@ -4326,7 +4326,7 @@
           <p:cNvPr id="27" name="">
             <a:extLst xmlns:a="http://schemas.openxmlformats.org/drawingml/2006/main">
               <a:ext uri="{FF2B5EF4-FFF2-40B4-BE49-F238E27FC236}">
-                <a16:creationId xmlns:a16="http://schemas.microsoft.com/office/drawing/2014/main" id="{46DC8CF1-3852-493F-AF8B-1779E7AF431A}"/>
+                <a16:creationId xmlns:a16="http://schemas.microsoft.com/office/drawing/2014/main" id="{A01EABF6-1D0A-4A08-B8A5-F409EA35B444}"/>
               </a:ext>
             </a:extLst>
           </p:cNvPr>
@@ -4358,7 +4358,7 @@
           <p:cNvPr id="28" name="">
             <a:extLst xmlns:a="http://schemas.openxmlformats.org/drawingml/2006/main">
               <a:ext uri="{FF2B5EF4-FFF2-40B4-BE49-F238E27FC236}">
-                <a16:creationId xmlns:a16="http://schemas.microsoft.com/office/drawing/2014/main" id="{FD547D73-F472-46F7-951D-D20DF27DA79C}"/>
+                <a16:creationId xmlns:a16="http://schemas.microsoft.com/office/drawing/2014/main" id="{01A1CCBE-7231-49B0-9F81-45597DA24C6E}"/>
               </a:ext>
             </a:extLst>
           </p:cNvPr>
@@ -4415,7 +4415,7 @@
           <p:cNvPr id="29" name="">
             <a:extLst xmlns:a="http://schemas.openxmlformats.org/drawingml/2006/main">
               <a:ext uri="{FF2B5EF4-FFF2-40B4-BE49-F238E27FC236}">
-                <a16:creationId xmlns:a16="http://schemas.microsoft.com/office/drawing/2014/main" id="{851B7256-41BC-4882-AEE1-768CC0E0616A}"/>
+                <a16:creationId xmlns:a16="http://schemas.microsoft.com/office/drawing/2014/main" id="{31E94781-6A92-4304-9C45-825F0E50C056}"/>
               </a:ext>
             </a:extLst>
           </p:cNvPr>
@@ -4470,7 +4470,7 @@
     </p:spTree>
     <p:extLst>
       <p:ext uri="{BB962C8B-B14F-4D97-AF65-F5344CB8AC3E}">
-        <p14:creationId xmlns:p14="http://schemas.microsoft.com/office/powerpoint/2010/main" val="777464891"/>
+        <p14:creationId xmlns:p14="http://schemas.microsoft.com/office/powerpoint/2010/main" val="726144357"/>
       </p:ext>
     </p:extLst>
   </p:cSld>
@@ -4501,7 +4501,7 @@
           <p:cNvPr id="28" name="">
             <a:extLst xmlns:a="http://schemas.openxmlformats.org/drawingml/2006/main">
               <a:ext uri="{FF2B5EF4-FFF2-40B4-BE49-F238E27FC236}">
-                <a16:creationId xmlns:a16="http://schemas.microsoft.com/office/drawing/2014/main" id="{56BFDF8E-07FF-48C7-A104-F44F5DC33274}"/>
+                <a16:creationId xmlns:a16="http://schemas.microsoft.com/office/drawing/2014/main" id="{4F2FF295-3939-4694-B199-9589871E0295}"/>
               </a:ext>
             </a:extLst>
           </p:cNvPr>
@@ -4531,7 +4531,7 @@
           <p:cNvPr id="2" name="">
             <a:extLst xmlns:a="http://schemas.openxmlformats.org/drawingml/2006/main">
               <a:ext uri="{FF2B5EF4-FFF2-40B4-BE49-F238E27FC236}">
-                <a16:creationId xmlns:a16="http://schemas.microsoft.com/office/drawing/2014/main" id="{FAD1F040-9BE4-48D9-861F-52C7A7FD2610}"/>
+                <a16:creationId xmlns:a16="http://schemas.microsoft.com/office/drawing/2014/main" id="{CFBC937D-80EB-491B-B5AB-38CA511579B5}"/>
               </a:ext>
             </a:extLst>
           </p:cNvPr>
@@ -4588,7 +4588,7 @@
           <p:cNvPr id="3" name="">
             <a:extLst xmlns:a="http://schemas.openxmlformats.org/drawingml/2006/main">
               <a:ext uri="{FF2B5EF4-FFF2-40B4-BE49-F238E27FC236}">
-                <a16:creationId xmlns:a16="http://schemas.microsoft.com/office/drawing/2014/main" id="{30478096-D4C2-4C05-AE39-BBE8DEE30D15}"/>
+                <a16:creationId xmlns:a16="http://schemas.microsoft.com/office/drawing/2014/main" id="{00A9D2D8-5BB9-4E67-9064-36894E2FC7BF}"/>
               </a:ext>
             </a:extLst>
           </p:cNvPr>
@@ -4645,7 +4645,7 @@
           <p:cNvPr id="4" name="">
             <a:extLst xmlns:a="http://schemas.openxmlformats.org/drawingml/2006/main">
               <a:ext uri="{FF2B5EF4-FFF2-40B4-BE49-F238E27FC236}">
-                <a16:creationId xmlns:a16="http://schemas.microsoft.com/office/drawing/2014/main" id="{D299DCBC-FDAA-4DF9-8477-2CB4EF9BDD49}"/>
+                <a16:creationId xmlns:a16="http://schemas.microsoft.com/office/drawing/2014/main" id="{584F2183-3B49-4BFE-92F3-640BBA8193A7}"/>
               </a:ext>
             </a:extLst>
           </p:cNvPr>
@@ -4702,7 +4702,7 @@
           <p:cNvPr id="5" name="">
             <a:extLst xmlns:a="http://schemas.openxmlformats.org/drawingml/2006/main">
               <a:ext uri="{FF2B5EF4-FFF2-40B4-BE49-F238E27FC236}">
-                <a16:creationId xmlns:a16="http://schemas.microsoft.com/office/drawing/2014/main" id="{9863CDAE-4721-4502-9D4C-5297044D387C}"/>
+                <a16:creationId xmlns:a16="http://schemas.microsoft.com/office/drawing/2014/main" id="{A81FDB95-F895-4604-98E6-D4D2DB7CF74E}"/>
               </a:ext>
             </a:extLst>
           </p:cNvPr>
@@ -4732,7 +4732,7 @@
           <p:cNvPr id="6" name="">
             <a:extLst xmlns:a="http://schemas.openxmlformats.org/drawingml/2006/main">
               <a:ext uri="{FF2B5EF4-FFF2-40B4-BE49-F238E27FC236}">
-                <a16:creationId xmlns:a16="http://schemas.microsoft.com/office/drawing/2014/main" id="{1483BDF3-9A6B-45E4-9FB4-131BB050001F}"/>
+                <a16:creationId xmlns:a16="http://schemas.microsoft.com/office/drawing/2014/main" id="{54720745-BAC2-46F1-989F-5714E98D2E63}"/>
               </a:ext>
             </a:extLst>
           </p:cNvPr>
@@ -4789,7 +4789,7 @@
           <p:cNvPr id="7" name="">
             <a:extLst xmlns:a="http://schemas.openxmlformats.org/drawingml/2006/main">
               <a:ext uri="{FF2B5EF4-FFF2-40B4-BE49-F238E27FC236}">
-                <a16:creationId xmlns:a16="http://schemas.microsoft.com/office/drawing/2014/main" id="{BFCDC0E2-F3F5-4A2F-8634-44904D15BACA}"/>
+                <a16:creationId xmlns:a16="http://schemas.microsoft.com/office/drawing/2014/main" id="{14B41FAC-200E-406E-8D1E-1579262975A8}"/>
               </a:ext>
             </a:extLst>
           </p:cNvPr>
@@ -4846,7 +4846,7 @@
           <p:cNvPr id="8" name="">
             <a:extLst xmlns:a="http://schemas.openxmlformats.org/drawingml/2006/main">
               <a:ext uri="{FF2B5EF4-FFF2-40B4-BE49-F238E27FC236}">
-                <a16:creationId xmlns:a16="http://schemas.microsoft.com/office/drawing/2014/main" id="{77FA4988-A64D-4074-A624-8D9D2E87024D}"/>
+                <a16:creationId xmlns:a16="http://schemas.microsoft.com/office/drawing/2014/main" id="{51F6452D-74B5-46C7-AB73-BB224F62B3F7}"/>
               </a:ext>
             </a:extLst>
           </p:cNvPr>
@@ -4880,7 +4880,7 @@
           <p:cNvPr id="9" name="">
             <a:extLst xmlns:a="http://schemas.openxmlformats.org/drawingml/2006/main">
               <a:ext uri="{FF2B5EF4-FFF2-40B4-BE49-F238E27FC236}">
-                <a16:creationId xmlns:a16="http://schemas.microsoft.com/office/drawing/2014/main" id="{BDC10C5A-BE4C-4D1E-966E-27C5860B70C1}"/>
+                <a16:creationId xmlns:a16="http://schemas.microsoft.com/office/drawing/2014/main" id="{C464CB35-2A4A-438A-B61D-44BC2EE06BF6}"/>
               </a:ext>
             </a:extLst>
           </p:cNvPr>
@@ -4910,7 +4910,7 @@
           <p:cNvPr id="10" name="">
             <a:extLst xmlns:a="http://schemas.openxmlformats.org/drawingml/2006/main">
               <a:ext uri="{FF2B5EF4-FFF2-40B4-BE49-F238E27FC236}">
-                <a16:creationId xmlns:a16="http://schemas.microsoft.com/office/drawing/2014/main" id="{0D4C4079-98F1-437F-B82F-DDEA0F11D4D5}"/>
+                <a16:creationId xmlns:a16="http://schemas.microsoft.com/office/drawing/2014/main" id="{E3B582D1-DEE3-4DB6-827D-F3F856159EA1}"/>
               </a:ext>
             </a:extLst>
           </p:cNvPr>
@@ -4967,7 +4967,7 @@
           <p:cNvPr id="11" name="">
             <a:extLst xmlns:a="http://schemas.openxmlformats.org/drawingml/2006/main">
               <a:ext uri="{FF2B5EF4-FFF2-40B4-BE49-F238E27FC236}">
-                <a16:creationId xmlns:a16="http://schemas.microsoft.com/office/drawing/2014/main" id="{622F9DC5-BF5B-4E07-AB11-A60D4531A928}"/>
+                <a16:creationId xmlns:a16="http://schemas.microsoft.com/office/drawing/2014/main" id="{7FCFB8BD-3A00-4994-9C03-8EF23837AA3B}"/>
               </a:ext>
             </a:extLst>
           </p:cNvPr>
@@ -5024,7 +5024,7 @@
           <p:cNvPr id="12" name="">
             <a:extLst xmlns:a="http://schemas.openxmlformats.org/drawingml/2006/main">
               <a:ext uri="{FF2B5EF4-FFF2-40B4-BE49-F238E27FC236}">
-                <a16:creationId xmlns:a16="http://schemas.microsoft.com/office/drawing/2014/main" id="{BD2089EC-232A-438C-B2FA-E713A2C72C1F}"/>
+                <a16:creationId xmlns:a16="http://schemas.microsoft.com/office/drawing/2014/main" id="{13933EE4-00E9-4637-BF52-CEDD64124188}"/>
               </a:ext>
             </a:extLst>
           </p:cNvPr>
@@ -5081,7 +5081,7 @@
           <p:cNvPr id="13" name="">
             <a:extLst xmlns:a="http://schemas.openxmlformats.org/drawingml/2006/main">
               <a:ext uri="{FF2B5EF4-FFF2-40B4-BE49-F238E27FC236}">
-                <a16:creationId xmlns:a16="http://schemas.microsoft.com/office/drawing/2014/main" id="{ADA42845-70B5-45EB-B2A0-A8E4AE628EB7}"/>
+                <a16:creationId xmlns:a16="http://schemas.microsoft.com/office/drawing/2014/main" id="{AF7B379F-E059-4E18-8EDB-013D7A6517A6}"/>
               </a:ext>
             </a:extLst>
           </p:cNvPr>
@@ -5115,7 +5115,7 @@
           <p:cNvPr id="14" name="">
             <a:extLst xmlns:a="http://schemas.openxmlformats.org/drawingml/2006/main">
               <a:ext uri="{FF2B5EF4-FFF2-40B4-BE49-F238E27FC236}">
-                <a16:creationId xmlns:a16="http://schemas.microsoft.com/office/drawing/2014/main" id="{E680E627-E0B6-4B38-BEE7-99457A872C54}"/>
+                <a16:creationId xmlns:a16="http://schemas.microsoft.com/office/drawing/2014/main" id="{A7F97407-8BD0-4D7D-BAEC-EAD83B34C872}"/>
               </a:ext>
             </a:extLst>
           </p:cNvPr>
@@ -5145,7 +5145,7 @@
           <p:cNvPr id="15" name="">
             <a:extLst xmlns:a="http://schemas.openxmlformats.org/drawingml/2006/main">
               <a:ext uri="{FF2B5EF4-FFF2-40B4-BE49-F238E27FC236}">
-                <a16:creationId xmlns:a16="http://schemas.microsoft.com/office/drawing/2014/main" id="{38AF30D8-7361-47F6-8BE8-6E20AB8C8334}"/>
+                <a16:creationId xmlns:a16="http://schemas.microsoft.com/office/drawing/2014/main" id="{E0CB0711-FF4D-4FBF-8288-FD29A48CDB65}"/>
               </a:ext>
             </a:extLst>
           </p:cNvPr>
@@ -5202,7 +5202,7 @@
           <p:cNvPr id="16" name="">
             <a:extLst xmlns:a="http://schemas.openxmlformats.org/drawingml/2006/main">
               <a:ext uri="{FF2B5EF4-FFF2-40B4-BE49-F238E27FC236}">
-                <a16:creationId xmlns:a16="http://schemas.microsoft.com/office/drawing/2014/main" id="{3CFF1F33-2E83-4574-A25D-EA1993B9E83A}"/>
+                <a16:creationId xmlns:a16="http://schemas.microsoft.com/office/drawing/2014/main" id="{9A1CBE1C-7CE5-4216-AB3A-C3314EC5EC6B}"/>
               </a:ext>
             </a:extLst>
           </p:cNvPr>
@@ -5259,7 +5259,7 @@
           <p:cNvPr id="17" name="">
             <a:extLst xmlns:a="http://schemas.openxmlformats.org/drawingml/2006/main">
               <a:ext uri="{FF2B5EF4-FFF2-40B4-BE49-F238E27FC236}">
-                <a16:creationId xmlns:a16="http://schemas.microsoft.com/office/drawing/2014/main" id="{D49C75D7-C5FE-41CC-BCF1-67F35E1E880F}"/>
+                <a16:creationId xmlns:a16="http://schemas.microsoft.com/office/drawing/2014/main" id="{98FC5216-350A-4913-99AF-0A9260F4CB69}"/>
               </a:ext>
             </a:extLst>
           </p:cNvPr>
@@ -5316,7 +5316,7 @@
           <p:cNvPr id="18" name="">
             <a:extLst xmlns:a="http://schemas.openxmlformats.org/drawingml/2006/main">
               <a:ext uri="{FF2B5EF4-FFF2-40B4-BE49-F238E27FC236}">
-                <a16:creationId xmlns:a16="http://schemas.microsoft.com/office/drawing/2014/main" id="{A0B3380D-BB90-4724-8D78-5C0C0BF372F7}"/>
+                <a16:creationId xmlns:a16="http://schemas.microsoft.com/office/drawing/2014/main" id="{AB423D95-95AC-422A-B49C-4149048778FC}"/>
               </a:ext>
             </a:extLst>
           </p:cNvPr>
@@ -5350,7 +5350,7 @@
           <p:cNvPr id="19" name="">
             <a:extLst xmlns:a="http://schemas.openxmlformats.org/drawingml/2006/main">
               <a:ext uri="{FF2B5EF4-FFF2-40B4-BE49-F238E27FC236}">
-                <a16:creationId xmlns:a16="http://schemas.microsoft.com/office/drawing/2014/main" id="{BA4A2DC8-4F74-484B-AAD2-299CB6D64B32}"/>
+                <a16:creationId xmlns:a16="http://schemas.microsoft.com/office/drawing/2014/main" id="{B249DD36-003C-4E8E-978E-9E505856E66B}"/>
               </a:ext>
             </a:extLst>
           </p:cNvPr>
@@ -5380,7 +5380,7 @@
           <p:cNvPr id="20" name="">
             <a:extLst xmlns:a="http://schemas.openxmlformats.org/drawingml/2006/main">
               <a:ext uri="{FF2B5EF4-FFF2-40B4-BE49-F238E27FC236}">
-                <a16:creationId xmlns:a16="http://schemas.microsoft.com/office/drawing/2014/main" id="{556C72D0-33F0-4EF3-A2D7-557ACDFFF253}"/>
+                <a16:creationId xmlns:a16="http://schemas.microsoft.com/office/drawing/2014/main" id="{C5259E60-5645-4165-825D-5BC6793C16EC}"/>
               </a:ext>
             </a:extLst>
           </p:cNvPr>
@@ -5437,7 +5437,7 @@
           <p:cNvPr id="21" name="">
             <a:extLst xmlns:a="http://schemas.openxmlformats.org/drawingml/2006/main">
               <a:ext uri="{FF2B5EF4-FFF2-40B4-BE49-F238E27FC236}">
-                <a16:creationId xmlns:a16="http://schemas.microsoft.com/office/drawing/2014/main" id="{2B279759-BEDC-4493-AD7F-E1C48AADD03B}"/>
+                <a16:creationId xmlns:a16="http://schemas.microsoft.com/office/drawing/2014/main" id="{87C0AF5D-EF20-4370-B062-5037AB1EEC6B}"/>
               </a:ext>
             </a:extLst>
           </p:cNvPr>
@@ -5494,7 +5494,7 @@
           <p:cNvPr id="22" name="">
             <a:extLst xmlns:a="http://schemas.openxmlformats.org/drawingml/2006/main">
               <a:ext uri="{FF2B5EF4-FFF2-40B4-BE49-F238E27FC236}">
-                <a16:creationId xmlns:a16="http://schemas.microsoft.com/office/drawing/2014/main" id="{8A82EDD8-4BE6-49B4-B8A6-BD8E5801D346}"/>
+                <a16:creationId xmlns:a16="http://schemas.microsoft.com/office/drawing/2014/main" id="{A9DCB0C9-6565-47AE-9DB0-8BF1139FA951}"/>
               </a:ext>
             </a:extLst>
           </p:cNvPr>
@@ -5551,7 +5551,7 @@
           <p:cNvPr id="23" name="">
             <a:extLst xmlns:a="http://schemas.openxmlformats.org/drawingml/2006/main">
               <a:ext uri="{FF2B5EF4-FFF2-40B4-BE49-F238E27FC236}">
-                <a16:creationId xmlns:a16="http://schemas.microsoft.com/office/drawing/2014/main" id="{812730F3-FA61-4834-A5DD-14E1EE07DB86}"/>
+                <a16:creationId xmlns:a16="http://schemas.microsoft.com/office/drawing/2014/main" id="{858F9D39-A11A-4B69-A28E-6BE63A86A9E5}"/>
               </a:ext>
             </a:extLst>
           </p:cNvPr>
@@ -5585,7 +5585,7 @@
           <p:cNvPr id="24" name="">
             <a:extLst xmlns:a="http://schemas.openxmlformats.org/drawingml/2006/main">
               <a:ext uri="{FF2B5EF4-FFF2-40B4-BE49-F238E27FC236}">
-                <a16:creationId xmlns:a16="http://schemas.microsoft.com/office/drawing/2014/main" id="{8F664F83-0163-43B6-9BE0-7DA38A7A35F8}"/>
+                <a16:creationId xmlns:a16="http://schemas.microsoft.com/office/drawing/2014/main" id="{7D8ADDA0-AE15-41D2-B86E-BB6E0FFE42E3}"/>
               </a:ext>
             </a:extLst>
           </p:cNvPr>
@@ -5615,7 +5615,7 @@
           <p:cNvPr id="25" name="">
             <a:extLst xmlns:a="http://schemas.openxmlformats.org/drawingml/2006/main">
               <a:ext uri="{FF2B5EF4-FFF2-40B4-BE49-F238E27FC236}">
-                <a16:creationId xmlns:a16="http://schemas.microsoft.com/office/drawing/2014/main" id="{EA2121DF-15AC-4152-92CE-CCC3D803AFDF}"/>
+                <a16:creationId xmlns:a16="http://schemas.microsoft.com/office/drawing/2014/main" id="{5659445D-9EED-419E-AA19-BCBDA1473871}"/>
               </a:ext>
             </a:extLst>
           </p:cNvPr>
@@ -5672,7 +5672,7 @@
           <p:cNvPr id="26" name="">
             <a:extLst xmlns:a="http://schemas.openxmlformats.org/drawingml/2006/main">
               <a:ext uri="{FF2B5EF4-FFF2-40B4-BE49-F238E27FC236}">
-                <a16:creationId xmlns:a16="http://schemas.microsoft.com/office/drawing/2014/main" id="{D2B4D182-3F19-4313-8DA4-346C8DD2AEDC}"/>
+                <a16:creationId xmlns:a16="http://schemas.microsoft.com/office/drawing/2014/main" id="{6F2E9FFA-E174-4C60-9A6C-2A111F094893}"/>
               </a:ext>
             </a:extLst>
           </p:cNvPr>
@@ -5729,7 +5729,7 @@
           <p:cNvPr id="27" name="">
             <a:extLst xmlns:a="http://schemas.openxmlformats.org/drawingml/2006/main">
               <a:ext uri="{FF2B5EF4-FFF2-40B4-BE49-F238E27FC236}">
-                <a16:creationId xmlns:a16="http://schemas.microsoft.com/office/drawing/2014/main" id="{F0EEAD3E-10E9-4EF1-BCD8-8D5552833350}"/>
+                <a16:creationId xmlns:a16="http://schemas.microsoft.com/office/drawing/2014/main" id="{7F8BB8C6-823B-4DC4-BF89-C849362D3FF0}"/>
               </a:ext>
             </a:extLst>
           </p:cNvPr>
@@ -5784,7 +5784,7 @@
     </p:spTree>
     <p:extLst>
       <p:ext uri="{BB962C8B-B14F-4D97-AF65-F5344CB8AC3E}">
-        <p14:creationId xmlns:p14="http://schemas.microsoft.com/office/powerpoint/2010/main" val="454899055"/>
+        <p14:creationId xmlns:p14="http://schemas.microsoft.com/office/powerpoint/2010/main" val="1905888806"/>
       </p:ext>
     </p:extLst>
   </p:cSld>
@@ -5815,7 +5815,7 @@
           <p:cNvPr id="21" name="">
             <a:extLst xmlns:a="http://schemas.openxmlformats.org/drawingml/2006/main">
               <a:ext uri="{FF2B5EF4-FFF2-40B4-BE49-F238E27FC236}">
-                <a16:creationId xmlns:a16="http://schemas.microsoft.com/office/drawing/2014/main" id="{0505E90A-E3C7-435C-8E5E-5777A3CCF088}"/>
+                <a16:creationId xmlns:a16="http://schemas.microsoft.com/office/drawing/2014/main" id="{B702E075-EA18-4424-BABA-0DC4849455ED}"/>
               </a:ext>
             </a:extLst>
           </p:cNvPr>
@@ -5845,7 +5845,7 @@
           <p:cNvPr id="2" name="">
             <a:extLst xmlns:a="http://schemas.openxmlformats.org/drawingml/2006/main">
               <a:ext uri="{FF2B5EF4-FFF2-40B4-BE49-F238E27FC236}">
-                <a16:creationId xmlns:a16="http://schemas.microsoft.com/office/drawing/2014/main" id="{E9157973-A460-4539-904D-B2727BAA8C4F}"/>
+                <a16:creationId xmlns:a16="http://schemas.microsoft.com/office/drawing/2014/main" id="{82AE9AAF-5381-4361-8D42-CFA8CA3DEED5}"/>
               </a:ext>
             </a:extLst>
           </p:cNvPr>
@@ -5902,7 +5902,7 @@
           <p:cNvPr id="3" name="">
             <a:extLst xmlns:a="http://schemas.openxmlformats.org/drawingml/2006/main">
               <a:ext uri="{FF2B5EF4-FFF2-40B4-BE49-F238E27FC236}">
-                <a16:creationId xmlns:a16="http://schemas.microsoft.com/office/drawing/2014/main" id="{E465AE3A-3ED4-4028-B9F7-DCD2FC6FF5C7}"/>
+                <a16:creationId xmlns:a16="http://schemas.microsoft.com/office/drawing/2014/main" id="{853E40F7-395B-4E95-B03B-4D01AF7EA9B6}"/>
               </a:ext>
             </a:extLst>
           </p:cNvPr>
@@ -5959,7 +5959,7 @@
           <p:cNvPr id="4" name="">
             <a:extLst xmlns:a="http://schemas.openxmlformats.org/drawingml/2006/main">
               <a:ext uri="{FF2B5EF4-FFF2-40B4-BE49-F238E27FC236}">
-                <a16:creationId xmlns:a16="http://schemas.microsoft.com/office/drawing/2014/main" id="{C5BE5FDC-7B74-4A30-BB07-29C17CFB81E5}"/>
+                <a16:creationId xmlns:a16="http://schemas.microsoft.com/office/drawing/2014/main" id="{E791D52C-073F-4AA6-893B-A4B8D667C9FF}"/>
               </a:ext>
             </a:extLst>
           </p:cNvPr>
@@ -6016,7 +6016,7 @@
           <p:cNvPr id="5" name="">
             <a:extLst xmlns:a="http://schemas.openxmlformats.org/drawingml/2006/main">
               <a:ext uri="{FF2B5EF4-FFF2-40B4-BE49-F238E27FC236}">
-                <a16:creationId xmlns:a16="http://schemas.microsoft.com/office/drawing/2014/main" id="{E0ABB2AC-12B5-4FC3-A312-2DB8ECD2CE42}"/>
+                <a16:creationId xmlns:a16="http://schemas.microsoft.com/office/drawing/2014/main" id="{2ED2DC41-C487-4097-9D96-B411E47C7274}"/>
               </a:ext>
             </a:extLst>
           </p:cNvPr>
@@ -6046,7 +6046,7 @@
           <p:cNvPr id="6" name="">
             <a:extLst xmlns:a="http://schemas.openxmlformats.org/drawingml/2006/main">
               <a:ext uri="{FF2B5EF4-FFF2-40B4-BE49-F238E27FC236}">
-                <a16:creationId xmlns:a16="http://schemas.microsoft.com/office/drawing/2014/main" id="{93E43EE7-7A96-49E0-9036-3291B2A0AF29}"/>
+                <a16:creationId xmlns:a16="http://schemas.microsoft.com/office/drawing/2014/main" id="{03260BD4-E191-43EE-A069-DCE44E4D3650}"/>
               </a:ext>
             </a:extLst>
           </p:cNvPr>
@@ -6103,7 +6103,7 @@
           <p:cNvPr id="7" name="">
             <a:extLst xmlns:a="http://schemas.openxmlformats.org/drawingml/2006/main">
               <a:ext uri="{FF2B5EF4-FFF2-40B4-BE49-F238E27FC236}">
-                <a16:creationId xmlns:a16="http://schemas.microsoft.com/office/drawing/2014/main" id="{8F2A7560-A32A-4DF5-AE81-32241A552573}"/>
+                <a16:creationId xmlns:a16="http://schemas.microsoft.com/office/drawing/2014/main" id="{1E7DACD6-5185-4122-9460-05805ADB8F8E}"/>
               </a:ext>
             </a:extLst>
           </p:cNvPr>
@@ -6160,7 +6160,7 @@
           <p:cNvPr id="8" name="">
             <a:extLst xmlns:a="http://schemas.openxmlformats.org/drawingml/2006/main">
               <a:ext uri="{FF2B5EF4-FFF2-40B4-BE49-F238E27FC236}">
-                <a16:creationId xmlns:a16="http://schemas.microsoft.com/office/drawing/2014/main" id="{0E3D6FFB-2343-4AA0-97EA-52059B517394}"/>
+                <a16:creationId xmlns:a16="http://schemas.microsoft.com/office/drawing/2014/main" id="{85FAF8B2-2216-4803-AE26-2C12C4CF78DD}"/>
               </a:ext>
             </a:extLst>
           </p:cNvPr>
@@ -6194,7 +6194,7 @@
           <p:cNvPr id="9" name="">
             <a:extLst xmlns:a="http://schemas.openxmlformats.org/drawingml/2006/main">
               <a:ext uri="{FF2B5EF4-FFF2-40B4-BE49-F238E27FC236}">
-                <a16:creationId xmlns:a16="http://schemas.microsoft.com/office/drawing/2014/main" id="{0AFDBB15-A734-4D89-9A95-86193437FE13}"/>
+                <a16:creationId xmlns:a16="http://schemas.microsoft.com/office/drawing/2014/main" id="{549093EC-4517-40D7-AAB2-94091413C6AD}"/>
               </a:ext>
             </a:extLst>
           </p:cNvPr>
@@ -6224,7 +6224,7 @@
           <p:cNvPr id="10" name="">
             <a:extLst xmlns:a="http://schemas.openxmlformats.org/drawingml/2006/main">
               <a:ext uri="{FF2B5EF4-FFF2-40B4-BE49-F238E27FC236}">
-                <a16:creationId xmlns:a16="http://schemas.microsoft.com/office/drawing/2014/main" id="{26001E79-F69A-4FDF-B11E-24B65D05D587}"/>
+                <a16:creationId xmlns:a16="http://schemas.microsoft.com/office/drawing/2014/main" id="{0C7C9187-16E7-4065-82BC-F6D904BE064B}"/>
               </a:ext>
             </a:extLst>
           </p:cNvPr>
@@ -6281,7 +6281,7 @@
           <p:cNvPr id="11" name="">
             <a:extLst xmlns:a="http://schemas.openxmlformats.org/drawingml/2006/main">
               <a:ext uri="{FF2B5EF4-FFF2-40B4-BE49-F238E27FC236}">
-                <a16:creationId xmlns:a16="http://schemas.microsoft.com/office/drawing/2014/main" id="{D6576A7C-7858-46C1-9FC8-14B99C0441BD}"/>
+                <a16:creationId xmlns:a16="http://schemas.microsoft.com/office/drawing/2014/main" id="{6378DE9B-1C35-4B90-B3CF-8C360D7ABC6A}"/>
               </a:ext>
             </a:extLst>
           </p:cNvPr>
@@ -6366,7 +6366,7 @@
           <p:cNvPr id="12" name="">
             <a:extLst xmlns:a="http://schemas.openxmlformats.org/drawingml/2006/main">
               <a:ext uri="{FF2B5EF4-FFF2-40B4-BE49-F238E27FC236}">
-                <a16:creationId xmlns:a16="http://schemas.microsoft.com/office/drawing/2014/main" id="{F9ED972C-E8F3-4EC7-898B-E8C27F3C2BE0}"/>
+                <a16:creationId xmlns:a16="http://schemas.microsoft.com/office/drawing/2014/main" id="{1B9A0C1F-7117-470E-A70A-16AE3CCCB11A}"/>
               </a:ext>
             </a:extLst>
           </p:cNvPr>
@@ -6400,7 +6400,7 @@
           <p:cNvPr id="13" name="">
             <a:extLst xmlns:a="http://schemas.openxmlformats.org/drawingml/2006/main">
               <a:ext uri="{FF2B5EF4-FFF2-40B4-BE49-F238E27FC236}">
-                <a16:creationId xmlns:a16="http://schemas.microsoft.com/office/drawing/2014/main" id="{AF017AFA-702D-42B2-977D-80BB4DA74B1E}"/>
+                <a16:creationId xmlns:a16="http://schemas.microsoft.com/office/drawing/2014/main" id="{C44C8DE0-56FC-45E3-AE30-3AB3EC38A1AF}"/>
               </a:ext>
             </a:extLst>
           </p:cNvPr>
@@ -6430,7 +6430,7 @@
           <p:cNvPr id="14" name="">
             <a:extLst xmlns:a="http://schemas.openxmlformats.org/drawingml/2006/main">
               <a:ext uri="{FF2B5EF4-FFF2-40B4-BE49-F238E27FC236}">
-                <a16:creationId xmlns:a16="http://schemas.microsoft.com/office/drawing/2014/main" id="{3DB501C8-9738-451F-B92E-78905A32700E}"/>
+                <a16:creationId xmlns:a16="http://schemas.microsoft.com/office/drawing/2014/main" id="{95BB14D9-853C-4498-BF3D-8875F0228CE5}"/>
               </a:ext>
             </a:extLst>
           </p:cNvPr>
@@ -6487,7 +6487,7 @@
           <p:cNvPr id="15" name="">
             <a:extLst xmlns:a="http://schemas.openxmlformats.org/drawingml/2006/main">
               <a:ext uri="{FF2B5EF4-FFF2-40B4-BE49-F238E27FC236}">
-                <a16:creationId xmlns:a16="http://schemas.microsoft.com/office/drawing/2014/main" id="{687CE262-B68C-41DB-BDC9-8F192936BEAA}"/>
+                <a16:creationId xmlns:a16="http://schemas.microsoft.com/office/drawing/2014/main" id="{BA5B2D69-AC36-4646-893C-54ADDCAEDD7C}"/>
               </a:ext>
             </a:extLst>
           </p:cNvPr>
@@ -6572,7 +6572,7 @@
           <p:cNvPr id="16" name="">
             <a:extLst xmlns:a="http://schemas.openxmlformats.org/drawingml/2006/main">
               <a:ext uri="{FF2B5EF4-FFF2-40B4-BE49-F238E27FC236}">
-                <a16:creationId xmlns:a16="http://schemas.microsoft.com/office/drawing/2014/main" id="{D50DF43F-BF2D-4A9D-9838-D822F5C0FA9D}"/>
+                <a16:creationId xmlns:a16="http://schemas.microsoft.com/office/drawing/2014/main" id="{51774487-05E9-4D60-A86C-9DA6319242BC}"/>
               </a:ext>
             </a:extLst>
           </p:cNvPr>
@@ -6606,7 +6606,7 @@
           <p:cNvPr id="17" name="">
             <a:extLst xmlns:a="http://schemas.openxmlformats.org/drawingml/2006/main">
               <a:ext uri="{FF2B5EF4-FFF2-40B4-BE49-F238E27FC236}">
-                <a16:creationId xmlns:a16="http://schemas.microsoft.com/office/drawing/2014/main" id="{C6D4922D-8C38-4DD8-AF01-614CD0954B35}"/>
+                <a16:creationId xmlns:a16="http://schemas.microsoft.com/office/drawing/2014/main" id="{8AA4323C-E865-472A-AA49-521160F901BD}"/>
               </a:ext>
             </a:extLst>
           </p:cNvPr>
@@ -6636,7 +6636,7 @@
           <p:cNvPr id="18" name="">
             <a:extLst xmlns:a="http://schemas.openxmlformats.org/drawingml/2006/main">
               <a:ext uri="{FF2B5EF4-FFF2-40B4-BE49-F238E27FC236}">
-                <a16:creationId xmlns:a16="http://schemas.microsoft.com/office/drawing/2014/main" id="{3626E03F-BDD8-4384-A50F-5F5EDEF15DAD}"/>
+                <a16:creationId xmlns:a16="http://schemas.microsoft.com/office/drawing/2014/main" id="{BE46EA13-5832-4BE5-9D15-A4DCA1AFE4C5}"/>
               </a:ext>
             </a:extLst>
           </p:cNvPr>
@@ -6693,7 +6693,7 @@
           <p:cNvPr id="19" name="">
             <a:extLst xmlns:a="http://schemas.openxmlformats.org/drawingml/2006/main">
               <a:ext uri="{FF2B5EF4-FFF2-40B4-BE49-F238E27FC236}">
-                <a16:creationId xmlns:a16="http://schemas.microsoft.com/office/drawing/2014/main" id="{959CED67-E2F6-4A26-A1ED-66A9C2C807D2}"/>
+                <a16:creationId xmlns:a16="http://schemas.microsoft.com/office/drawing/2014/main" id="{D11FF730-9451-4D0B-A348-FA4F0DE1F1FD}"/>
               </a:ext>
             </a:extLst>
           </p:cNvPr>
@@ -6778,7 +6778,7 @@
           <p:cNvPr id="20" name="">
             <a:extLst xmlns:a="http://schemas.openxmlformats.org/drawingml/2006/main">
               <a:ext uri="{FF2B5EF4-FFF2-40B4-BE49-F238E27FC236}">
-                <a16:creationId xmlns:a16="http://schemas.microsoft.com/office/drawing/2014/main" id="{DAA9BB31-C37F-4962-9D55-3A86A03EEF7B}"/>
+                <a16:creationId xmlns:a16="http://schemas.microsoft.com/office/drawing/2014/main" id="{A4F547E8-1A15-475F-9B9A-1DCFF97C73E8}"/>
               </a:ext>
             </a:extLst>
           </p:cNvPr>
@@ -6833,7 +6833,7 @@
     </p:spTree>
     <p:extLst>
       <p:ext uri="{BB962C8B-B14F-4D97-AF65-F5344CB8AC3E}">
-        <p14:creationId xmlns:p14="http://schemas.microsoft.com/office/powerpoint/2010/main" val="1915273613"/>
+        <p14:creationId xmlns:p14="http://schemas.microsoft.com/office/powerpoint/2010/main" val="1349503764"/>
       </p:ext>
     </p:extLst>
   </p:cSld>
@@ -6864,7 +6864,7 @@
           <p:cNvPr id="24" name="">
             <a:extLst xmlns:a="http://schemas.openxmlformats.org/drawingml/2006/main">
               <a:ext uri="{FF2B5EF4-FFF2-40B4-BE49-F238E27FC236}">
-                <a16:creationId xmlns:a16="http://schemas.microsoft.com/office/drawing/2014/main" id="{E11A604A-C8B3-44F8-9BC7-A29905A145AF}"/>
+                <a16:creationId xmlns:a16="http://schemas.microsoft.com/office/drawing/2014/main" id="{FF680D9D-AA84-4D4F-AF11-BBD4941E75BC}"/>
               </a:ext>
             </a:extLst>
           </p:cNvPr>
@@ -6894,7 +6894,7 @@
           <p:cNvPr id="2" name="">
             <a:extLst xmlns:a="http://schemas.openxmlformats.org/drawingml/2006/main">
               <a:ext uri="{FF2B5EF4-FFF2-40B4-BE49-F238E27FC236}">
-                <a16:creationId xmlns:a16="http://schemas.microsoft.com/office/drawing/2014/main" id="{8C41C4FE-E47C-462D-AFB9-B8E2727D848E}"/>
+                <a16:creationId xmlns:a16="http://schemas.microsoft.com/office/drawing/2014/main" id="{F79D3072-332C-4A68-BA2E-416473722C9A}"/>
               </a:ext>
             </a:extLst>
           </p:cNvPr>
@@ -6951,7 +6951,7 @@
           <p:cNvPr id="3" name="">
             <a:extLst xmlns:a="http://schemas.openxmlformats.org/drawingml/2006/main">
               <a:ext uri="{FF2B5EF4-FFF2-40B4-BE49-F238E27FC236}">
-                <a16:creationId xmlns:a16="http://schemas.microsoft.com/office/drawing/2014/main" id="{D1C4D743-0FA5-42ED-A8E1-9013A33E2576}"/>
+                <a16:creationId xmlns:a16="http://schemas.microsoft.com/office/drawing/2014/main" id="{F7EAFFC2-D458-464D-A766-E8FBCE7FA707}"/>
               </a:ext>
             </a:extLst>
           </p:cNvPr>
@@ -7008,7 +7008,7 @@
           <p:cNvPr id="4" name="">
             <a:extLst xmlns:a="http://schemas.openxmlformats.org/drawingml/2006/main">
               <a:ext uri="{FF2B5EF4-FFF2-40B4-BE49-F238E27FC236}">
-                <a16:creationId xmlns:a16="http://schemas.microsoft.com/office/drawing/2014/main" id="{629BF2DC-6B02-4A89-938C-DBF0A9E4BEAF}"/>
+                <a16:creationId xmlns:a16="http://schemas.microsoft.com/office/drawing/2014/main" id="{FE7109B2-3F0E-4469-8AB4-616C61CC908B}"/>
               </a:ext>
             </a:extLst>
           </p:cNvPr>
@@ -7065,7 +7065,7 @@
           <p:cNvPr id="5" name="">
             <a:extLst xmlns:a="http://schemas.openxmlformats.org/drawingml/2006/main">
               <a:ext uri="{FF2B5EF4-FFF2-40B4-BE49-F238E27FC236}">
-                <a16:creationId xmlns:a16="http://schemas.microsoft.com/office/drawing/2014/main" id="{536E794F-2035-4083-A72C-F2BB96D5DBFE}"/>
+                <a16:creationId xmlns:a16="http://schemas.microsoft.com/office/drawing/2014/main" id="{53C10B36-805B-4EDF-A9B9-419D76FC10DE}"/>
               </a:ext>
             </a:extLst>
           </p:cNvPr>
@@ -7095,7 +7095,7 @@
           <p:cNvPr id="6" name="">
             <a:extLst xmlns:a="http://schemas.openxmlformats.org/drawingml/2006/main">
               <a:ext uri="{FF2B5EF4-FFF2-40B4-BE49-F238E27FC236}">
-                <a16:creationId xmlns:a16="http://schemas.microsoft.com/office/drawing/2014/main" id="{8C0BF498-6046-467B-84FD-F47034BA31EB}"/>
+                <a16:creationId xmlns:a16="http://schemas.microsoft.com/office/drawing/2014/main" id="{4D015494-86C6-41AE-AE28-CB695000B2C0}"/>
               </a:ext>
             </a:extLst>
           </p:cNvPr>
@@ -7152,7 +7152,7 @@
           <p:cNvPr id="7" name="">
             <a:extLst xmlns:a="http://schemas.openxmlformats.org/drawingml/2006/main">
               <a:ext uri="{FF2B5EF4-FFF2-40B4-BE49-F238E27FC236}">
-                <a16:creationId xmlns:a16="http://schemas.microsoft.com/office/drawing/2014/main" id="{502909B0-EAF5-4B3A-8121-CC06719DDB00}"/>
+                <a16:creationId xmlns:a16="http://schemas.microsoft.com/office/drawing/2014/main" id="{5C0E47D1-70AD-4D2D-8568-1BDCF716EC9C}"/>
               </a:ext>
             </a:extLst>
           </p:cNvPr>
@@ -7209,7 +7209,7 @@
           <p:cNvPr id="8" name="">
             <a:extLst xmlns:a="http://schemas.openxmlformats.org/drawingml/2006/main">
               <a:ext uri="{FF2B5EF4-FFF2-40B4-BE49-F238E27FC236}">
-                <a16:creationId xmlns:a16="http://schemas.microsoft.com/office/drawing/2014/main" id="{8D243D94-4B7E-415F-A4B7-295C7F05B5CC}"/>
+                <a16:creationId xmlns:a16="http://schemas.microsoft.com/office/drawing/2014/main" id="{DAB3EF1C-01B5-44BB-92B8-FF4E38B20269}"/>
               </a:ext>
             </a:extLst>
           </p:cNvPr>
@@ -7243,7 +7243,7 @@
           <p:cNvPr id="9" name="">
             <a:extLst xmlns:a="http://schemas.openxmlformats.org/drawingml/2006/main">
               <a:ext uri="{FF2B5EF4-FFF2-40B4-BE49-F238E27FC236}">
-                <a16:creationId xmlns:a16="http://schemas.microsoft.com/office/drawing/2014/main" id="{17CEBCF2-1879-4AA4-9715-A8A45017239F}"/>
+                <a16:creationId xmlns:a16="http://schemas.microsoft.com/office/drawing/2014/main" id="{89C2D772-B79A-45A1-8A12-400023AD8AC3}"/>
               </a:ext>
             </a:extLst>
           </p:cNvPr>
@@ -7273,7 +7273,7 @@
           <p:cNvPr id="10" name="">
             <a:extLst xmlns:a="http://schemas.openxmlformats.org/drawingml/2006/main">
               <a:ext uri="{FF2B5EF4-FFF2-40B4-BE49-F238E27FC236}">
-                <a16:creationId xmlns:a16="http://schemas.microsoft.com/office/drawing/2014/main" id="{4962E094-8F13-46BB-80BD-AC838521497A}"/>
+                <a16:creationId xmlns:a16="http://schemas.microsoft.com/office/drawing/2014/main" id="{EB07F9D2-F434-45D0-A3FB-972A4FA9BCC0}"/>
               </a:ext>
             </a:extLst>
           </p:cNvPr>
@@ -7330,7 +7330,7 @@
           <p:cNvPr id="11" name="">
             <a:extLst xmlns:a="http://schemas.openxmlformats.org/drawingml/2006/main">
               <a:ext uri="{FF2B5EF4-FFF2-40B4-BE49-F238E27FC236}">
-                <a16:creationId xmlns:a16="http://schemas.microsoft.com/office/drawing/2014/main" id="{C62944E1-5AC8-4C11-A50D-75B46B1D3A30}"/>
+                <a16:creationId xmlns:a16="http://schemas.microsoft.com/office/drawing/2014/main" id="{3F7CFCB8-ED1D-4E0D-89BD-AF4A66DC2A26}"/>
               </a:ext>
             </a:extLst>
           </p:cNvPr>
@@ -7410,7 +7410,7 @@
           <p:cNvPr id="12" name="">
             <a:extLst xmlns:a="http://schemas.openxmlformats.org/drawingml/2006/main">
               <a:ext uri="{FF2B5EF4-FFF2-40B4-BE49-F238E27FC236}">
-                <a16:creationId xmlns:a16="http://schemas.microsoft.com/office/drawing/2014/main" id="{B049EB69-881C-49D3-BB3A-76E14758312F}"/>
+                <a16:creationId xmlns:a16="http://schemas.microsoft.com/office/drawing/2014/main" id="{563E285E-4135-4F8D-828B-6FF59EB42338}"/>
               </a:ext>
             </a:extLst>
           </p:cNvPr>
@@ -7444,7 +7444,7 @@
           <p:cNvPr id="13" name="">
             <a:extLst xmlns:a="http://schemas.openxmlformats.org/drawingml/2006/main">
               <a:ext uri="{FF2B5EF4-FFF2-40B4-BE49-F238E27FC236}">
-                <a16:creationId xmlns:a16="http://schemas.microsoft.com/office/drawing/2014/main" id="{94C10833-54AE-4E06-BB80-D375C69CF5A9}"/>
+                <a16:creationId xmlns:a16="http://schemas.microsoft.com/office/drawing/2014/main" id="{529CA013-C1CB-431E-B53F-7AEE75336B2E}"/>
               </a:ext>
             </a:extLst>
           </p:cNvPr>
@@ -7474,7 +7474,7 @@
           <p:cNvPr id="14" name="">
             <a:extLst xmlns:a="http://schemas.openxmlformats.org/drawingml/2006/main">
               <a:ext uri="{FF2B5EF4-FFF2-40B4-BE49-F238E27FC236}">
-                <a16:creationId xmlns:a16="http://schemas.microsoft.com/office/drawing/2014/main" id="{27F6FA22-AAD3-44E3-935F-AC8B8F025A78}"/>
+                <a16:creationId xmlns:a16="http://schemas.microsoft.com/office/drawing/2014/main" id="{1F5A1CAA-FE19-4DA0-91F5-128304C88710}"/>
               </a:ext>
             </a:extLst>
           </p:cNvPr>
@@ -7531,7 +7531,7 @@
           <p:cNvPr id="15" name="">
             <a:extLst xmlns:a="http://schemas.openxmlformats.org/drawingml/2006/main">
               <a:ext uri="{FF2B5EF4-FFF2-40B4-BE49-F238E27FC236}">
-                <a16:creationId xmlns:a16="http://schemas.microsoft.com/office/drawing/2014/main" id="{6E2F84AC-3E9E-46F2-83FE-DEC40CB68CF1}"/>
+                <a16:creationId xmlns:a16="http://schemas.microsoft.com/office/drawing/2014/main" id="{BF69D168-BD2F-4A3E-A3F0-77B383BF716D}"/>
               </a:ext>
             </a:extLst>
           </p:cNvPr>
@@ -7611,7 +7611,7 @@
           <p:cNvPr id="16" name="">
             <a:extLst xmlns:a="http://schemas.openxmlformats.org/drawingml/2006/main">
               <a:ext uri="{FF2B5EF4-FFF2-40B4-BE49-F238E27FC236}">
-                <a16:creationId xmlns:a16="http://schemas.microsoft.com/office/drawing/2014/main" id="{A58A4D40-2D7E-45C5-A042-96A3A20998C0}"/>
+                <a16:creationId xmlns:a16="http://schemas.microsoft.com/office/drawing/2014/main" id="{971A53E9-3884-41E0-A0CE-72F1687F2C4D}"/>
               </a:ext>
             </a:extLst>
           </p:cNvPr>
@@ -7645,7 +7645,7 @@
           <p:cNvPr id="17" name="">
             <a:extLst xmlns:a="http://schemas.openxmlformats.org/drawingml/2006/main">
               <a:ext uri="{FF2B5EF4-FFF2-40B4-BE49-F238E27FC236}">
-                <a16:creationId xmlns:a16="http://schemas.microsoft.com/office/drawing/2014/main" id="{46CBEB03-E297-4250-9369-66C3E3DF5C12}"/>
+                <a16:creationId xmlns:a16="http://schemas.microsoft.com/office/drawing/2014/main" id="{0742F722-277B-4875-985E-1B8A459A2543}"/>
               </a:ext>
             </a:extLst>
           </p:cNvPr>
@@ -7675,7 +7675,7 @@
           <p:cNvPr id="18" name="">
             <a:extLst xmlns:a="http://schemas.openxmlformats.org/drawingml/2006/main">
               <a:ext uri="{FF2B5EF4-FFF2-40B4-BE49-F238E27FC236}">
-                <a16:creationId xmlns:a16="http://schemas.microsoft.com/office/drawing/2014/main" id="{17006211-87CB-4A98-858E-217D668EFFDB}"/>
+                <a16:creationId xmlns:a16="http://schemas.microsoft.com/office/drawing/2014/main" id="{7090828F-32CA-4176-B1DA-63EB27BFC8CF}"/>
               </a:ext>
             </a:extLst>
           </p:cNvPr>
@@ -7732,7 +7732,7 @@
           <p:cNvPr id="19" name="">
             <a:extLst xmlns:a="http://schemas.openxmlformats.org/drawingml/2006/main">
               <a:ext uri="{FF2B5EF4-FFF2-40B4-BE49-F238E27FC236}">
-                <a16:creationId xmlns:a16="http://schemas.microsoft.com/office/drawing/2014/main" id="{A86EF49F-E240-4571-8A14-E43997BB35FB}"/>
+                <a16:creationId xmlns:a16="http://schemas.microsoft.com/office/drawing/2014/main" id="{C016863B-B103-4B5D-9182-3B4C090CD834}"/>
               </a:ext>
             </a:extLst>
           </p:cNvPr>
@@ -7789,7 +7789,7 @@
           <p:cNvPr id="20" name="">
             <a:extLst xmlns:a="http://schemas.openxmlformats.org/drawingml/2006/main">
               <a:ext uri="{FF2B5EF4-FFF2-40B4-BE49-F238E27FC236}">
-                <a16:creationId xmlns:a16="http://schemas.microsoft.com/office/drawing/2014/main" id="{DFA979BD-9B2D-4D62-85F7-DFA00FA21C19}"/>
+                <a16:creationId xmlns:a16="http://schemas.microsoft.com/office/drawing/2014/main" id="{934E9784-25E0-459B-AB59-27852CA578C8}"/>
               </a:ext>
             </a:extLst>
           </p:cNvPr>
@@ -7823,7 +7823,7 @@
           <p:cNvPr id="21" name="">
             <a:extLst xmlns:a="http://schemas.openxmlformats.org/drawingml/2006/main">
               <a:ext uri="{FF2B5EF4-FFF2-40B4-BE49-F238E27FC236}">
-                <a16:creationId xmlns:a16="http://schemas.microsoft.com/office/drawing/2014/main" id="{5125B189-2AE0-4615-A04C-0BC250DD4D48}"/>
+                <a16:creationId xmlns:a16="http://schemas.microsoft.com/office/drawing/2014/main" id="{1150C6FA-D16B-4260-A569-026B93F75062}"/>
               </a:ext>
             </a:extLst>
           </p:cNvPr>
@@ -7853,7 +7853,7 @@
           <p:cNvPr id="22" name="">
             <a:extLst xmlns:a="http://schemas.openxmlformats.org/drawingml/2006/main">
               <a:ext uri="{FF2B5EF4-FFF2-40B4-BE49-F238E27FC236}">
-                <a16:creationId xmlns:a16="http://schemas.microsoft.com/office/drawing/2014/main" id="{1885F13D-BE4E-4916-9EF8-E3CA6D0D04D2}"/>
+                <a16:creationId xmlns:a16="http://schemas.microsoft.com/office/drawing/2014/main" id="{F364D32B-5A55-4B68-959A-E5C4445C04D5}"/>
               </a:ext>
             </a:extLst>
           </p:cNvPr>
@@ -7910,7 +7910,7 @@
           <p:cNvPr id="23" name="">
             <a:extLst xmlns:a="http://schemas.openxmlformats.org/drawingml/2006/main">
               <a:ext uri="{FF2B5EF4-FFF2-40B4-BE49-F238E27FC236}">
-                <a16:creationId xmlns:a16="http://schemas.microsoft.com/office/drawing/2014/main" id="{A5A1689C-4E66-428A-8373-A653A286C0C7}"/>
+                <a16:creationId xmlns:a16="http://schemas.microsoft.com/office/drawing/2014/main" id="{55BCCF29-D8CB-4F79-B51C-EAE618AFEEFF}"/>
               </a:ext>
             </a:extLst>
           </p:cNvPr>
@@ -7965,7 +7965,7 @@
     </p:spTree>
     <p:extLst>
       <p:ext uri="{BB962C8B-B14F-4D97-AF65-F5344CB8AC3E}">
-        <p14:creationId xmlns:p14="http://schemas.microsoft.com/office/powerpoint/2010/main" val="1044401070"/>
+        <p14:creationId xmlns:p14="http://schemas.microsoft.com/office/powerpoint/2010/main" val="11526978"/>
       </p:ext>
     </p:extLst>
   </p:cSld>
@@ -7996,7 +7996,7 @@
           <p:cNvPr id="21" name="">
             <a:extLst xmlns:a="http://schemas.openxmlformats.org/drawingml/2006/main">
               <a:ext uri="{FF2B5EF4-FFF2-40B4-BE49-F238E27FC236}">
-                <a16:creationId xmlns:a16="http://schemas.microsoft.com/office/drawing/2014/main" id="{FB0AD079-0A59-4396-AD1F-8DA41640EABB}"/>
+                <a16:creationId xmlns:a16="http://schemas.microsoft.com/office/drawing/2014/main" id="{01FCEEBA-84C5-4D67-961D-B5A46D3D8C3A}"/>
               </a:ext>
             </a:extLst>
           </p:cNvPr>
@@ -8026,7 +8026,7 @@
           <p:cNvPr id="2" name="">
             <a:extLst xmlns:a="http://schemas.openxmlformats.org/drawingml/2006/main">
               <a:ext uri="{FF2B5EF4-FFF2-40B4-BE49-F238E27FC236}">
-                <a16:creationId xmlns:a16="http://schemas.microsoft.com/office/drawing/2014/main" id="{BE015CC3-6870-4E7E-A1E9-9831F3848B4C}"/>
+                <a16:creationId xmlns:a16="http://schemas.microsoft.com/office/drawing/2014/main" id="{77657922-C07D-4FE5-9133-D93A7445A1BD}"/>
               </a:ext>
             </a:extLst>
           </p:cNvPr>
@@ -8083,7 +8083,7 @@
           <p:cNvPr id="3" name="">
             <a:extLst xmlns:a="http://schemas.openxmlformats.org/drawingml/2006/main">
               <a:ext uri="{FF2B5EF4-FFF2-40B4-BE49-F238E27FC236}">
-                <a16:creationId xmlns:a16="http://schemas.microsoft.com/office/drawing/2014/main" id="{A08A6F69-AC6C-475A-858C-FAE0598D1AED}"/>
+                <a16:creationId xmlns:a16="http://schemas.microsoft.com/office/drawing/2014/main" id="{F1F39478-19B1-49C4-A886-9735495F5393}"/>
               </a:ext>
             </a:extLst>
           </p:cNvPr>
@@ -8140,7 +8140,7 @@
           <p:cNvPr id="4" name="">
             <a:extLst xmlns:a="http://schemas.openxmlformats.org/drawingml/2006/main">
               <a:ext uri="{FF2B5EF4-FFF2-40B4-BE49-F238E27FC236}">
-                <a16:creationId xmlns:a16="http://schemas.microsoft.com/office/drawing/2014/main" id="{BFBCF097-8A1C-46D4-9870-3B8B18A79C33}"/>
+                <a16:creationId xmlns:a16="http://schemas.microsoft.com/office/drawing/2014/main" id="{A4DCFAB7-E992-43FA-89FA-83F6467BCF55}"/>
               </a:ext>
             </a:extLst>
           </p:cNvPr>
@@ -8197,7 +8197,7 @@
           <p:cNvPr id="5" name="">
             <a:extLst xmlns:a="http://schemas.openxmlformats.org/drawingml/2006/main">
               <a:ext uri="{FF2B5EF4-FFF2-40B4-BE49-F238E27FC236}">
-                <a16:creationId xmlns:a16="http://schemas.microsoft.com/office/drawing/2014/main" id="{C11FFCAC-5F53-498C-90A2-9C6972120389}"/>
+                <a16:creationId xmlns:a16="http://schemas.microsoft.com/office/drawing/2014/main" id="{BFFD0AA1-2D41-493F-A8FF-173336496B7F}"/>
               </a:ext>
             </a:extLst>
           </p:cNvPr>
@@ -8227,7 +8227,7 @@
           <p:cNvPr id="6" name="">
             <a:extLst xmlns:a="http://schemas.openxmlformats.org/drawingml/2006/main">
               <a:ext uri="{FF2B5EF4-FFF2-40B4-BE49-F238E27FC236}">
-                <a16:creationId xmlns:a16="http://schemas.microsoft.com/office/drawing/2014/main" id="{DAF23BAA-5C24-426B-BABC-2864ACA02BEB}"/>
+                <a16:creationId xmlns:a16="http://schemas.microsoft.com/office/drawing/2014/main" id="{90B26552-72A1-4388-98F4-B7C1EF501EBE}"/>
               </a:ext>
             </a:extLst>
           </p:cNvPr>
@@ -8284,7 +8284,7 @@
           <p:cNvPr id="7" name="">
             <a:extLst xmlns:a="http://schemas.openxmlformats.org/drawingml/2006/main">
               <a:ext uri="{FF2B5EF4-FFF2-40B4-BE49-F238E27FC236}">
-                <a16:creationId xmlns:a16="http://schemas.microsoft.com/office/drawing/2014/main" id="{5B56E925-5EF8-4A28-875D-1E9AE4600DFD}"/>
+                <a16:creationId xmlns:a16="http://schemas.microsoft.com/office/drawing/2014/main" id="{5E7C2EDE-2FB1-4629-85B8-D2F28370C23C}"/>
               </a:ext>
             </a:extLst>
           </p:cNvPr>
@@ -8341,7 +8341,7 @@
           <p:cNvPr id="8" name="">
             <a:extLst xmlns:a="http://schemas.openxmlformats.org/drawingml/2006/main">
               <a:ext uri="{FF2B5EF4-FFF2-40B4-BE49-F238E27FC236}">
-                <a16:creationId xmlns:a16="http://schemas.microsoft.com/office/drawing/2014/main" id="{FF4C8F8D-1E1A-4E33-BB52-C51381024ACB}"/>
+                <a16:creationId xmlns:a16="http://schemas.microsoft.com/office/drawing/2014/main" id="{FFAB2CBB-73F4-40EE-99A8-1D175944587C}"/>
               </a:ext>
             </a:extLst>
           </p:cNvPr>
@@ -8375,7 +8375,7 @@
           <p:cNvPr id="9" name="">
             <a:extLst xmlns:a="http://schemas.openxmlformats.org/drawingml/2006/main">
               <a:ext uri="{FF2B5EF4-FFF2-40B4-BE49-F238E27FC236}">
-                <a16:creationId xmlns:a16="http://schemas.microsoft.com/office/drawing/2014/main" id="{71D66F0A-A1B1-4AB6-A37C-B896AC8A2DD5}"/>
+                <a16:creationId xmlns:a16="http://schemas.microsoft.com/office/drawing/2014/main" id="{ACC2B061-EC76-438C-86E8-AB9701E397B6}"/>
               </a:ext>
             </a:extLst>
           </p:cNvPr>
@@ -8432,7 +8432,7 @@
           <p:cNvPr id="10" name="">
             <a:extLst xmlns:a="http://schemas.openxmlformats.org/drawingml/2006/main">
               <a:ext uri="{FF2B5EF4-FFF2-40B4-BE49-F238E27FC236}">
-                <a16:creationId xmlns:a16="http://schemas.microsoft.com/office/drawing/2014/main" id="{B2608C10-E58A-4554-9417-FB1164D3FCE5}"/>
+                <a16:creationId xmlns:a16="http://schemas.microsoft.com/office/drawing/2014/main" id="{2B5DE67A-E7B0-4C75-BCF5-22FDDDD09149}"/>
               </a:ext>
             </a:extLst>
           </p:cNvPr>
@@ -8489,7 +8489,7 @@
           <p:cNvPr id="11" name="">
             <a:extLst xmlns:a="http://schemas.openxmlformats.org/drawingml/2006/main">
               <a:ext uri="{FF2B5EF4-FFF2-40B4-BE49-F238E27FC236}">
-                <a16:creationId xmlns:a16="http://schemas.microsoft.com/office/drawing/2014/main" id="{CE421627-F74D-491F-86CC-E1AE93F3E349}"/>
+                <a16:creationId xmlns:a16="http://schemas.microsoft.com/office/drawing/2014/main" id="{FC9E7444-F428-4D32-9621-4622194CD226}"/>
               </a:ext>
             </a:extLst>
           </p:cNvPr>
@@ -8546,7 +8546,7 @@
           <p:cNvPr id="12" name="">
             <a:extLst xmlns:a="http://schemas.openxmlformats.org/drawingml/2006/main">
               <a:ext uri="{FF2B5EF4-FFF2-40B4-BE49-F238E27FC236}">
-                <a16:creationId xmlns:a16="http://schemas.microsoft.com/office/drawing/2014/main" id="{95192B89-6B2F-415B-9702-533DF659D9EF}"/>
+                <a16:creationId xmlns:a16="http://schemas.microsoft.com/office/drawing/2014/main" id="{B5AAFCA5-FF8B-4BDE-B3EB-EFBF55311C7F}"/>
               </a:ext>
             </a:extLst>
           </p:cNvPr>
@@ -8580,7 +8580,7 @@
           <p:cNvPr id="13" name="">
             <a:extLst xmlns:a="http://schemas.openxmlformats.org/drawingml/2006/main">
               <a:ext uri="{FF2B5EF4-FFF2-40B4-BE49-F238E27FC236}">
-                <a16:creationId xmlns:a16="http://schemas.microsoft.com/office/drawing/2014/main" id="{52301F7E-1535-418D-B48D-848E8537B5C2}"/>
+                <a16:creationId xmlns:a16="http://schemas.microsoft.com/office/drawing/2014/main" id="{19BD698D-E49F-4E49-B762-B97352953A13}"/>
               </a:ext>
             </a:extLst>
           </p:cNvPr>
@@ -8637,7 +8637,7 @@
           <p:cNvPr id="14" name="">
             <a:extLst xmlns:a="http://schemas.openxmlformats.org/drawingml/2006/main">
               <a:ext uri="{FF2B5EF4-FFF2-40B4-BE49-F238E27FC236}">
-                <a16:creationId xmlns:a16="http://schemas.microsoft.com/office/drawing/2014/main" id="{AC4400E6-F2F1-4D61-81ED-E60696110A6B}"/>
+                <a16:creationId xmlns:a16="http://schemas.microsoft.com/office/drawing/2014/main" id="{28CECCF7-F70B-437F-8FCE-F9765C19ADE0}"/>
               </a:ext>
             </a:extLst>
           </p:cNvPr>
@@ -8694,7 +8694,7 @@
           <p:cNvPr id="15" name="">
             <a:extLst xmlns:a="http://schemas.openxmlformats.org/drawingml/2006/main">
               <a:ext uri="{FF2B5EF4-FFF2-40B4-BE49-F238E27FC236}">
-                <a16:creationId xmlns:a16="http://schemas.microsoft.com/office/drawing/2014/main" id="{605A99F0-255C-479F-AAE5-E210F004C8D8}"/>
+                <a16:creationId xmlns:a16="http://schemas.microsoft.com/office/drawing/2014/main" id="{E817F2C7-DC7A-4994-95C7-A3A97AAF3CE0}"/>
               </a:ext>
             </a:extLst>
           </p:cNvPr>
@@ -8751,7 +8751,7 @@
           <p:cNvPr id="16" name="">
             <a:extLst xmlns:a="http://schemas.openxmlformats.org/drawingml/2006/main">
               <a:ext uri="{FF2B5EF4-FFF2-40B4-BE49-F238E27FC236}">
-                <a16:creationId xmlns:a16="http://schemas.microsoft.com/office/drawing/2014/main" id="{2FE15DCF-BA7D-4757-AD64-BCAE1100EF73}"/>
+                <a16:creationId xmlns:a16="http://schemas.microsoft.com/office/drawing/2014/main" id="{2D7AB7D5-EC86-4F27-9071-543B7CAF5979}"/>
               </a:ext>
             </a:extLst>
           </p:cNvPr>
@@ -8785,7 +8785,7 @@
           <p:cNvPr id="17" name="">
             <a:extLst xmlns:a="http://schemas.openxmlformats.org/drawingml/2006/main">
               <a:ext uri="{FF2B5EF4-FFF2-40B4-BE49-F238E27FC236}">
-                <a16:creationId xmlns:a16="http://schemas.microsoft.com/office/drawing/2014/main" id="{856E6307-EE0C-4161-8F3E-9E3874314463}"/>
+                <a16:creationId xmlns:a16="http://schemas.microsoft.com/office/drawing/2014/main" id="{41185FC0-C7B5-42E6-9DBE-542557EB9227}"/>
               </a:ext>
             </a:extLst>
           </p:cNvPr>
@@ -8842,7 +8842,7 @@
           <p:cNvPr id="18" name="">
             <a:extLst xmlns:a="http://schemas.openxmlformats.org/drawingml/2006/main">
               <a:ext uri="{FF2B5EF4-FFF2-40B4-BE49-F238E27FC236}">
-                <a16:creationId xmlns:a16="http://schemas.microsoft.com/office/drawing/2014/main" id="{550F2FDA-9E70-4BE5-B796-19A3F6DC49DF}"/>
+                <a16:creationId xmlns:a16="http://schemas.microsoft.com/office/drawing/2014/main" id="{E1B81963-5DF5-43EF-BD0A-9F82FA67476B}"/>
               </a:ext>
             </a:extLst>
           </p:cNvPr>
@@ -8899,7 +8899,7 @@
           <p:cNvPr id="19" name="">
             <a:extLst xmlns:a="http://schemas.openxmlformats.org/drawingml/2006/main">
               <a:ext uri="{FF2B5EF4-FFF2-40B4-BE49-F238E27FC236}">
-                <a16:creationId xmlns:a16="http://schemas.microsoft.com/office/drawing/2014/main" id="{0DC06DBB-687F-4917-B7BE-531EB776BF60}"/>
+                <a16:creationId xmlns:a16="http://schemas.microsoft.com/office/drawing/2014/main" id="{4F2732B0-92D3-46E1-9350-D6D4C28A9ECC}"/>
               </a:ext>
             </a:extLst>
           </p:cNvPr>
@@ -8956,7 +8956,7 @@
           <p:cNvPr id="20" name="">
             <a:extLst xmlns:a="http://schemas.openxmlformats.org/drawingml/2006/main">
               <a:ext uri="{FF2B5EF4-FFF2-40B4-BE49-F238E27FC236}">
-                <a16:creationId xmlns:a16="http://schemas.microsoft.com/office/drawing/2014/main" id="{22F396BC-36FA-4294-8E72-0D723B5BE6E7}"/>
+                <a16:creationId xmlns:a16="http://schemas.microsoft.com/office/drawing/2014/main" id="{42CD4F66-5D1D-421F-8CCA-27814B6A0FEE}"/>
               </a:ext>
             </a:extLst>
           </p:cNvPr>
@@ -9011,7 +9011,7 @@
     </p:spTree>
     <p:extLst>
       <p:ext uri="{BB962C8B-B14F-4D97-AF65-F5344CB8AC3E}">
-        <p14:creationId xmlns:p14="http://schemas.microsoft.com/office/powerpoint/2010/main" val="1580296739"/>
+        <p14:creationId xmlns:p14="http://schemas.microsoft.com/office/powerpoint/2010/main" val="1574730265"/>
       </p:ext>
     </p:extLst>
   </p:cSld>
@@ -9042,7 +9042,7 @@
           <p:cNvPr id="25" name="">
             <a:extLst xmlns:a="http://schemas.openxmlformats.org/drawingml/2006/main">
               <a:ext uri="{FF2B5EF4-FFF2-40B4-BE49-F238E27FC236}">
-                <a16:creationId xmlns:a16="http://schemas.microsoft.com/office/drawing/2014/main" id="{DB132418-4C10-4D9A-AB98-7BC7638A14BF}"/>
+                <a16:creationId xmlns:a16="http://schemas.microsoft.com/office/drawing/2014/main" id="{C335C730-D499-4487-87BE-A9798935C55C}"/>
               </a:ext>
             </a:extLst>
           </p:cNvPr>
@@ -9072,7 +9072,7 @@
           <p:cNvPr id="2" name="">
             <a:extLst xmlns:a="http://schemas.openxmlformats.org/drawingml/2006/main">
               <a:ext uri="{FF2B5EF4-FFF2-40B4-BE49-F238E27FC236}">
-                <a16:creationId xmlns:a16="http://schemas.microsoft.com/office/drawing/2014/main" id="{9F04120D-4B8E-48B1-9B6A-BBB92125F31A}"/>
+                <a16:creationId xmlns:a16="http://schemas.microsoft.com/office/drawing/2014/main" id="{95755CB6-06E6-44E2-882E-D57293969261}"/>
               </a:ext>
             </a:extLst>
           </p:cNvPr>
@@ -9129,7 +9129,7 @@
           <p:cNvPr id="3" name="">
             <a:extLst xmlns:a="http://schemas.openxmlformats.org/drawingml/2006/main">
               <a:ext uri="{FF2B5EF4-FFF2-40B4-BE49-F238E27FC236}">
-                <a16:creationId xmlns:a16="http://schemas.microsoft.com/office/drawing/2014/main" id="{72949BB9-2599-42C7-9FF2-3D79F87EB784}"/>
+                <a16:creationId xmlns:a16="http://schemas.microsoft.com/office/drawing/2014/main" id="{EC4294EE-CDDD-4413-B908-8F3619941060}"/>
               </a:ext>
             </a:extLst>
           </p:cNvPr>
@@ -9186,7 +9186,7 @@
           <p:cNvPr id="4" name="">
             <a:extLst xmlns:a="http://schemas.openxmlformats.org/drawingml/2006/main">
               <a:ext uri="{FF2B5EF4-FFF2-40B4-BE49-F238E27FC236}">
-                <a16:creationId xmlns:a16="http://schemas.microsoft.com/office/drawing/2014/main" id="{DE0C1E51-29C1-4DB0-B384-A210B72C9A72}"/>
+                <a16:creationId xmlns:a16="http://schemas.microsoft.com/office/drawing/2014/main" id="{A72B8757-0692-42BE-A230-FEDBBC491CBD}"/>
               </a:ext>
             </a:extLst>
           </p:cNvPr>
@@ -9243,7 +9243,7 @@
           <p:cNvPr id="5" name="">
             <a:extLst xmlns:a="http://schemas.openxmlformats.org/drawingml/2006/main">
               <a:ext uri="{FF2B5EF4-FFF2-40B4-BE49-F238E27FC236}">
-                <a16:creationId xmlns:a16="http://schemas.microsoft.com/office/drawing/2014/main" id="{30CD51A5-6FBA-4D83-80A5-3DB43F66B434}"/>
+                <a16:creationId xmlns:a16="http://schemas.microsoft.com/office/drawing/2014/main" id="{D96E8479-6CB7-4487-BAB1-86840335ED25}"/>
               </a:ext>
             </a:extLst>
           </p:cNvPr>
@@ -9273,7 +9273,7 @@
           <p:cNvPr id="6" name="">
             <a:extLst xmlns:a="http://schemas.openxmlformats.org/drawingml/2006/main">
               <a:ext uri="{FF2B5EF4-FFF2-40B4-BE49-F238E27FC236}">
-                <a16:creationId xmlns:a16="http://schemas.microsoft.com/office/drawing/2014/main" id="{594513DC-B847-4822-9C65-2CA5309E53CC}"/>
+                <a16:creationId xmlns:a16="http://schemas.microsoft.com/office/drawing/2014/main" id="{2DB18B97-ACEF-411B-B73D-3C1FE273DD7F}"/>
               </a:ext>
             </a:extLst>
           </p:cNvPr>
@@ -9330,7 +9330,7 @@
           <p:cNvPr id="7" name="">
             <a:extLst xmlns:a="http://schemas.openxmlformats.org/drawingml/2006/main">
               <a:ext uri="{FF2B5EF4-FFF2-40B4-BE49-F238E27FC236}">
-                <a16:creationId xmlns:a16="http://schemas.microsoft.com/office/drawing/2014/main" id="{42156507-B2B1-478B-B182-036D25CE7289}"/>
+                <a16:creationId xmlns:a16="http://schemas.microsoft.com/office/drawing/2014/main" id="{9DDC9F94-987F-4149-A6FC-47955A39AE4D}"/>
               </a:ext>
             </a:extLst>
           </p:cNvPr>
@@ -9387,7 +9387,7 @@
           <p:cNvPr id="8" name="">
             <a:extLst xmlns:a="http://schemas.openxmlformats.org/drawingml/2006/main">
               <a:ext uri="{FF2B5EF4-FFF2-40B4-BE49-F238E27FC236}">
-                <a16:creationId xmlns:a16="http://schemas.microsoft.com/office/drawing/2014/main" id="{CF0C24E3-9942-4AA2-AF14-72D5FF7EF41C}"/>
+                <a16:creationId xmlns:a16="http://schemas.microsoft.com/office/drawing/2014/main" id="{93F1FDD7-9218-49B0-9BA7-5C795FA1354A}"/>
               </a:ext>
             </a:extLst>
           </p:cNvPr>
@@ -9421,7 +9421,7 @@
           <p:cNvPr id="9" name="">
             <a:extLst xmlns:a="http://schemas.openxmlformats.org/drawingml/2006/main">
               <a:ext uri="{FF2B5EF4-FFF2-40B4-BE49-F238E27FC236}">
-                <a16:creationId xmlns:a16="http://schemas.microsoft.com/office/drawing/2014/main" id="{F94A6D24-43A9-4C48-B67D-9752E5AE7777}"/>
+                <a16:creationId xmlns:a16="http://schemas.microsoft.com/office/drawing/2014/main" id="{DE03704D-3C5D-4EA2-9CC0-51609BA34B49}"/>
               </a:ext>
             </a:extLst>
           </p:cNvPr>
@@ -9453,7 +9453,7 @@
           <p:cNvPr id="10" name="">
             <a:extLst xmlns:a="http://schemas.openxmlformats.org/drawingml/2006/main">
               <a:ext uri="{FF2B5EF4-FFF2-40B4-BE49-F238E27FC236}">
-                <a16:creationId xmlns:a16="http://schemas.microsoft.com/office/drawing/2014/main" id="{D09F3926-6991-466D-8225-8C66DB3890BA}"/>
+                <a16:creationId xmlns:a16="http://schemas.microsoft.com/office/drawing/2014/main" id="{01CC710E-82FF-4014-BD52-36F342670FED}"/>
               </a:ext>
             </a:extLst>
           </p:cNvPr>
@@ -9510,7 +9510,7 @@
           <p:cNvPr id="11" name="">
             <a:extLst xmlns:a="http://schemas.openxmlformats.org/drawingml/2006/main">
               <a:ext uri="{FF2B5EF4-FFF2-40B4-BE49-F238E27FC236}">
-                <a16:creationId xmlns:a16="http://schemas.microsoft.com/office/drawing/2014/main" id="{D8DCB7C3-031F-4245-9791-EC05D64931D7}"/>
+                <a16:creationId xmlns:a16="http://schemas.microsoft.com/office/drawing/2014/main" id="{FBD793FA-67DD-4F6D-B307-08CC20BB1CC4}"/>
               </a:ext>
             </a:extLst>
           </p:cNvPr>
@@ -9567,7 +9567,7 @@
           <p:cNvPr id="12" name="">
             <a:extLst xmlns:a="http://schemas.openxmlformats.org/drawingml/2006/main">
               <a:ext uri="{FF2B5EF4-FFF2-40B4-BE49-F238E27FC236}">
-                <a16:creationId xmlns:a16="http://schemas.microsoft.com/office/drawing/2014/main" id="{EA75EBA1-A2C1-4F12-A822-4B53EF130AEB}"/>
+                <a16:creationId xmlns:a16="http://schemas.microsoft.com/office/drawing/2014/main" id="{9A95761B-D6A8-48D2-869D-E78CBEA2A1E8}"/>
               </a:ext>
             </a:extLst>
           </p:cNvPr>
@@ -9601,7 +9601,7 @@
           <p:cNvPr id="13" name="">
             <a:extLst xmlns:a="http://schemas.openxmlformats.org/drawingml/2006/main">
               <a:ext uri="{FF2B5EF4-FFF2-40B4-BE49-F238E27FC236}">
-                <a16:creationId xmlns:a16="http://schemas.microsoft.com/office/drawing/2014/main" id="{BF2283A4-5B9B-44A1-9157-14CC27572E1D}"/>
+                <a16:creationId xmlns:a16="http://schemas.microsoft.com/office/drawing/2014/main" id="{DA0DF067-A712-4E33-B15A-2B0D9999411C}"/>
               </a:ext>
             </a:extLst>
           </p:cNvPr>
@@ -9633,7 +9633,7 @@
           <p:cNvPr id="14" name="">
             <a:extLst xmlns:a="http://schemas.openxmlformats.org/drawingml/2006/main">
               <a:ext uri="{FF2B5EF4-FFF2-40B4-BE49-F238E27FC236}">
-                <a16:creationId xmlns:a16="http://schemas.microsoft.com/office/drawing/2014/main" id="{3588DB8E-940D-40D5-9494-D29636333366}"/>
+                <a16:creationId xmlns:a16="http://schemas.microsoft.com/office/drawing/2014/main" id="{9218DFB6-9C0F-43A4-A779-BB7DE775FA98}"/>
               </a:ext>
             </a:extLst>
           </p:cNvPr>
@@ -9690,7 +9690,7 @@
           <p:cNvPr id="15" name="">
             <a:extLst xmlns:a="http://schemas.openxmlformats.org/drawingml/2006/main">
               <a:ext uri="{FF2B5EF4-FFF2-40B4-BE49-F238E27FC236}">
-                <a16:creationId xmlns:a16="http://schemas.microsoft.com/office/drawing/2014/main" id="{C85EAA76-DB6C-4F4B-9E59-5F6EA573E9E2}"/>
+                <a16:creationId xmlns:a16="http://schemas.microsoft.com/office/drawing/2014/main" id="{C646E15B-A8C1-456F-94A1-31EAC43030AA}"/>
               </a:ext>
             </a:extLst>
           </p:cNvPr>
@@ -9747,7 +9747,7 @@
           <p:cNvPr id="16" name="">
             <a:extLst xmlns:a="http://schemas.openxmlformats.org/drawingml/2006/main">
               <a:ext uri="{FF2B5EF4-FFF2-40B4-BE49-F238E27FC236}">
-                <a16:creationId xmlns:a16="http://schemas.microsoft.com/office/drawing/2014/main" id="{9F17C613-A63A-4FD9-86AF-066EEF062AE7}"/>
+                <a16:creationId xmlns:a16="http://schemas.microsoft.com/office/drawing/2014/main" id="{FE017516-4274-4F35-85D1-A2410C20EE05}"/>
               </a:ext>
             </a:extLst>
           </p:cNvPr>
@@ -9781,7 +9781,7 @@
           <p:cNvPr id="17" name="">
             <a:extLst xmlns:a="http://schemas.openxmlformats.org/drawingml/2006/main">
               <a:ext uri="{FF2B5EF4-FFF2-40B4-BE49-F238E27FC236}">
-                <a16:creationId xmlns:a16="http://schemas.microsoft.com/office/drawing/2014/main" id="{CBD5625B-4511-43C0-A54D-395FE17A43A9}"/>
+                <a16:creationId xmlns:a16="http://schemas.microsoft.com/office/drawing/2014/main" id="{56C064E2-5B59-444A-B71B-E932D333CF87}"/>
               </a:ext>
             </a:extLst>
           </p:cNvPr>
@@ -9813,7 +9813,7 @@
           <p:cNvPr id="18" name="">
             <a:extLst xmlns:a="http://schemas.openxmlformats.org/drawingml/2006/main">
               <a:ext uri="{FF2B5EF4-FFF2-40B4-BE49-F238E27FC236}">
-                <a16:creationId xmlns:a16="http://schemas.microsoft.com/office/drawing/2014/main" id="{6DC821C3-0B4A-4EC6-9D6B-A19197D91DEE}"/>
+                <a16:creationId xmlns:a16="http://schemas.microsoft.com/office/drawing/2014/main" id="{575175A2-9AA0-4C39-88EB-748F0AF5843B}"/>
               </a:ext>
             </a:extLst>
           </p:cNvPr>
@@ -9870,7 +9870,7 @@
           <p:cNvPr id="19" name="">
             <a:extLst xmlns:a="http://schemas.openxmlformats.org/drawingml/2006/main">
               <a:ext uri="{FF2B5EF4-FFF2-40B4-BE49-F238E27FC236}">
-                <a16:creationId xmlns:a16="http://schemas.microsoft.com/office/drawing/2014/main" id="{2DAA82C3-57F0-4DD0-9F69-E5E14E1F7604}"/>
+                <a16:creationId xmlns:a16="http://schemas.microsoft.com/office/drawing/2014/main" id="{25EEB535-A0DC-405A-A3EE-4DA8009155FA}"/>
               </a:ext>
             </a:extLst>
           </p:cNvPr>
@@ -9927,7 +9927,7 @@
           <p:cNvPr id="20" name="">
             <a:extLst xmlns:a="http://schemas.openxmlformats.org/drawingml/2006/main">
               <a:ext uri="{FF2B5EF4-FFF2-40B4-BE49-F238E27FC236}">
-                <a16:creationId xmlns:a16="http://schemas.microsoft.com/office/drawing/2014/main" id="{E1C8FDF5-0036-491E-A85B-BD387BD79610}"/>
+                <a16:creationId xmlns:a16="http://schemas.microsoft.com/office/drawing/2014/main" id="{47DF4AF2-4F77-49BD-A48C-66650EC68755}"/>
               </a:ext>
             </a:extLst>
           </p:cNvPr>
@@ -9961,7 +9961,7 @@
           <p:cNvPr id="21" name="">
             <a:extLst xmlns:a="http://schemas.openxmlformats.org/drawingml/2006/main">
               <a:ext uri="{FF2B5EF4-FFF2-40B4-BE49-F238E27FC236}">
-                <a16:creationId xmlns:a16="http://schemas.microsoft.com/office/drawing/2014/main" id="{59293A52-7200-48C0-9631-19C20E8CA067}"/>
+                <a16:creationId xmlns:a16="http://schemas.microsoft.com/office/drawing/2014/main" id="{16548459-8110-47D1-83F2-DC8540FA792E}"/>
               </a:ext>
             </a:extLst>
           </p:cNvPr>
@@ -9993,7 +9993,7 @@
           <p:cNvPr id="22" name="">
             <a:extLst xmlns:a="http://schemas.openxmlformats.org/drawingml/2006/main">
               <a:ext uri="{FF2B5EF4-FFF2-40B4-BE49-F238E27FC236}">
-                <a16:creationId xmlns:a16="http://schemas.microsoft.com/office/drawing/2014/main" id="{9F75221C-980B-462A-8D8E-4830C3BE67ED}"/>
+                <a16:creationId xmlns:a16="http://schemas.microsoft.com/office/drawing/2014/main" id="{6DA87F90-FB4D-461F-8318-E921E9BEE600}"/>
               </a:ext>
             </a:extLst>
           </p:cNvPr>
@@ -10050,7 +10050,7 @@
           <p:cNvPr id="23" name="">
             <a:extLst xmlns:a="http://schemas.openxmlformats.org/drawingml/2006/main">
               <a:ext uri="{FF2B5EF4-FFF2-40B4-BE49-F238E27FC236}">
-                <a16:creationId xmlns:a16="http://schemas.microsoft.com/office/drawing/2014/main" id="{13308BAD-7379-46E9-8202-52B20A84B9CE}"/>
+                <a16:creationId xmlns:a16="http://schemas.microsoft.com/office/drawing/2014/main" id="{4ACA6052-674F-40A4-9EFD-17EF40E5119B}"/>
               </a:ext>
             </a:extLst>
           </p:cNvPr>
@@ -10097,7 +10097,7 @@
                 <a:ea typeface="Arial"/>
                 <a:cs typeface="Arial"/>
               </a:rPr>
-              <a:t>Review evidence with second owners; commit an identifiable final revision.</a:t>
+              <a:t>Review evidence with second owners; tag or revise after sign-off.</a:t>
             </a:r>
           </a:p>
         </p:txBody>
@@ -10107,7 +10107,7 @@
           <p:cNvPr id="24" name="">
             <a:extLst xmlns:a="http://schemas.openxmlformats.org/drawingml/2006/main">
               <a:ext uri="{FF2B5EF4-FFF2-40B4-BE49-F238E27FC236}">
-                <a16:creationId xmlns:a16="http://schemas.microsoft.com/office/drawing/2014/main" id="{8E77D5F8-7AC4-4021-8F58-E6B4BEA96BD1}"/>
+                <a16:creationId xmlns:a16="http://schemas.microsoft.com/office/drawing/2014/main" id="{B1F419FE-96C3-4DF1-B2CB-B54C30CE1100}"/>
               </a:ext>
             </a:extLst>
           </p:cNvPr>
@@ -10162,7 +10162,7 @@
     </p:spTree>
     <p:extLst>
       <p:ext uri="{BB962C8B-B14F-4D97-AF65-F5344CB8AC3E}">
-        <p14:creationId xmlns:p14="http://schemas.microsoft.com/office/powerpoint/2010/main" val="1080481855"/>
+        <p14:creationId xmlns:p14="http://schemas.microsoft.com/office/powerpoint/2010/main" val="442190222"/>
       </p:ext>
     </p:extLst>
   </p:cSld>

</xml_diff>